<commit_message>
Update presentation assets and metadata
Replit-Commit-Author: Agent
</commit_message>
<xml_diff>
--- a/presentation/Mish-Senior-Pitch.pptx
+++ b/presentation/Mish-Senior-Pitch.pptx
@@ -13,9 +13,10 @@
     <p:sldId id="261" r:id="rId7"/>
     <p:sldId id="262" r:id="rId8"/>
     <p:sldId id="263" r:id="rId9"/>
+    <p:sldId id="264" r:id="rId10"/>
   </p:sldIdLst>
   <p:notesMasterIdLst>
-    <p:notesMasterId r:id="rId10"/>
+    <p:notesMasterId r:id="rId11"/>
   </p:notesMasterIdLst>
   <p:sldSz cx="12192000" cy="6858000"/>
   <p:notesSz cx="6858000" cy="12192000"/>
@@ -1149,6 +1150,94 @@
             <a:fld id="{F7021451-1387-4CA6-816F-3879F97B5CBC}" type="slidenum">
               <a:rPr lang="en-US"/>
               <a:t>8</a:t>
+            </a:fld>
+            <a:endParaRPr lang="en-US"/>
+          </a:p>
+        </p:txBody>
+      </p:sp>
+    </p:spTree>
+    <p:extLst>
+      <p:ext uri="{BB962C8B-B14F-4D97-AF65-F5344CB8AC3E}">
+        <p14:creationId xmlns:p14="http://schemas.microsoft.com/office/powerpoint/2010/main" val="1024086991"/>
+      </p:ext>
+    </p:extLst>
+  </p:cSld>
+  <p:clrMapOvr>
+    <a:masterClrMapping/>
+  </p:clrMapOvr>
+</p:notes>
+</file>
+
+<file path=ppt/notesSlides/notesSlide9.xml><?xml version="1.0" encoding="utf-8"?>
+<p:notes xmlns:a="http://schemas.openxmlformats.org/drawingml/2006/main" xmlns:r="http://schemas.openxmlformats.org/officeDocument/2006/relationships" xmlns:p="http://schemas.openxmlformats.org/presentationml/2006/main">
+  <p:cSld>
+    <p:spTree>
+      <p:nvGrpSpPr>
+        <p:cNvPr id="1" name=""/>
+        <p:cNvGrpSpPr/>
+        <p:nvPr/>
+      </p:nvGrpSpPr>
+      <p:grpSpPr>
+        <a:xfrm>
+          <a:off x="0" y="0"/>
+          <a:ext cx="0" cy="0"/>
+          <a:chOff x="0" y="0"/>
+          <a:chExt cx="0" cy="0"/>
+        </a:xfrm>
+      </p:grpSpPr>
+      <p:sp>
+        <p:nvSpPr>
+          <p:cNvPr id="2" name="Slide Image Placeholder 1"/>
+          <p:cNvSpPr>
+            <a:spLocks noGrp="1" noRot="1" noChangeAspect="1"/>
+          </p:cNvSpPr>
+          <p:nvPr>
+            <p:ph type="sldImg"/>
+          </p:nvPr>
+        </p:nvSpPr>
+        <p:spPr/>
+      </p:sp>
+      <p:sp>
+        <p:nvSpPr>
+          <p:cNvPr id="3" name="Notes Placeholder 2"/>
+          <p:cNvSpPr>
+            <a:spLocks noGrp="1"/>
+          </p:cNvSpPr>
+          <p:nvPr>
+            <p:ph type="body" idx="1"/>
+          </p:nvPr>
+        </p:nvSpPr>
+        <p:spPr/>
+        <p:txBody>
+          <a:bodyPr/>
+          <a:lstStyle/>
+          <a:p>
+            <a:r>
+              <a:rPr lang="en-US" dirty="0"/>
+              <a:t/>
+            </a:r>
+            <a:endParaRPr lang="en-US" dirty="0"/>
+          </a:p>
+        </p:txBody>
+      </p:sp>
+      <p:sp>
+        <p:nvSpPr>
+          <p:cNvPr id="4" name="Slide Number Placeholder 3"/>
+          <p:cNvSpPr>
+            <a:spLocks noGrp="1"/>
+          </p:cNvSpPr>
+          <p:nvPr>
+            <p:ph type="sldNum" sz="quarter" idx="10"/>
+          </p:nvPr>
+        </p:nvSpPr>
+        <p:spPr/>
+        <p:txBody>
+          <a:bodyPr/>
+          <a:lstStyle/>
+          <a:p>
+            <a:fld id="{F7021451-1387-4CA6-816F-3879F97B5CBC}" type="slidenum">
+              <a:rPr lang="en-US"/>
+              <a:t>9</a:t>
             </a:fld>
             <a:endParaRPr lang="en-US"/>
           </a:p>
@@ -1613,7 +1702,7 @@
                 <a:ea typeface="Arial" pitchFamily="34" charset="-122"/>
                 <a:cs typeface="Arial" pitchFamily="34" charset="-120"/>
               </a:rPr>
-              <a:t>01 / 08</a:t>
+              <a:t>01 / 09</a:t>
             </a:r>
             <a:endParaRPr lang="en-US" sz="1000" dirty="0"/>
           </a:p>
@@ -2020,7 +2109,7 @@
                 <a:ea typeface="Arial" pitchFamily="34" charset="-122"/>
                 <a:cs typeface="Arial" pitchFamily="34" charset="-120"/>
               </a:rPr>
-              <a:t>02 / 08</a:t>
+              <a:t>02 / 09</a:t>
             </a:r>
             <a:endParaRPr lang="en-US" sz="1000" dirty="0"/>
           </a:p>
@@ -2688,7 +2777,7 @@
                 <a:ea typeface="Arial" pitchFamily="34" charset="-122"/>
                 <a:cs typeface="Arial" pitchFamily="34" charset="-120"/>
               </a:rPr>
-              <a:t>03 / 08</a:t>
+              <a:t>03 / 09</a:t>
             </a:r>
             <a:endParaRPr lang="en-US" sz="1000" dirty="0"/>
           </a:p>
@@ -3395,7 +3484,7 @@
                 <a:ea typeface="Arial" pitchFamily="34" charset="-122"/>
                 <a:cs typeface="Arial" pitchFamily="34" charset="-120"/>
               </a:rPr>
-              <a:t>04 / 08</a:t>
+              <a:t>04 / 09</a:t>
             </a:r>
             <a:endParaRPr lang="en-US" sz="1000" dirty="0"/>
           </a:p>
@@ -3575,7 +3664,7 @@
                 <a:ea typeface="Arial" pitchFamily="34" charset="-122"/>
                 <a:cs typeface="Arial" pitchFamily="34" charset="-120"/>
               </a:rPr>
-              <a:t>05 / 08</a:t>
+              <a:t>05 / 09</a:t>
             </a:r>
             <a:endParaRPr lang="en-US" sz="1000" dirty="0"/>
           </a:p>
@@ -4014,7 +4103,7 @@
                 <a:ea typeface="Arial" pitchFamily="34" charset="-122"/>
                 <a:cs typeface="Arial" pitchFamily="34" charset="-120"/>
               </a:rPr>
-              <a:t>06 // BUSINESS · 15 SEC</a:t>
+              <a:t>05 // MARKET · POSITIONING</a:t>
             </a:r>
             <a:endParaRPr lang="en-US" sz="1200" dirty="0"/>
           </a:p>
@@ -4092,7 +4181,7 @@
                 <a:ea typeface="Arial" pitchFamily="34" charset="-122"/>
                 <a:cs typeface="Arial" pitchFamily="34" charset="-120"/>
               </a:rPr>
-              <a:t>06 / 08</a:t>
+              <a:t>06 / 09</a:t>
             </a:r>
             <a:endParaRPr lang="en-US" sz="1000" dirty="0"/>
           </a:p>
@@ -4106,24 +4195,24 @@
         </p:nvSpPr>
         <p:spPr>
           <a:xfrm>
-            <a:off x="731520" y="1508760"/>
-            <a:ext cx="10698480" cy="1188720"/>
-          </a:xfrm>
-          <a:prstGeom prst="rect">
-            <a:avLst/>
-          </a:prstGeom>
-          <a:noFill/>
-          <a:ln/>
-        </p:spPr>
-        <p:txBody>
-          <a:bodyPr wrap="square" rtlCol="0" anchor="t"/>
-          <a:lstStyle/>
-          <a:p>
-            <a:pPr indent="0" marL="0">
-              <a:buNone/>
-            </a:pPr>
-            <a:r>
-              <a:rPr lang="en-US" sz="4400" b="1" dirty="0">
+            <a:off x="731520" y="1188720"/>
+            <a:ext cx="7315200" cy="822960"/>
+          </a:xfrm>
+          <a:prstGeom prst="rect">
+            <a:avLst/>
+          </a:prstGeom>
+          <a:noFill/>
+          <a:ln/>
+        </p:spPr>
+        <p:txBody>
+          <a:bodyPr wrap="square" rtlCol="0" anchor="ctr"/>
+          <a:lstStyle/>
+          <a:p>
+            <a:pPr indent="0" marL="0">
+              <a:buNone/>
+            </a:pPr>
+            <a:r>
+              <a:rPr lang="en-US" sz="3800" b="1" dirty="0">
                 <a:solidFill>
                   <a:srgbClr val="0F1F1A"/>
                 </a:solidFill>
@@ -4131,9 +4220,9 @@
                 <a:ea typeface="Arial" pitchFamily="34" charset="-122"/>
                 <a:cs typeface="Arial" pitchFamily="34" charset="-120"/>
               </a:rPr>
-              <a:t>Companies pay. Graduates start free.</a:t>
-            </a:r>
-            <a:endParaRPr lang="en-US" sz="4400" dirty="0"/>
+              <a:t>Market &amp; Competitors</a:t>
+            </a:r>
+            <a:endParaRPr lang="en-US" sz="3800" dirty="0"/>
           </a:p>
         </p:txBody>
       </p:sp>
@@ -4145,8 +4234,8 @@
         </p:nvSpPr>
         <p:spPr>
           <a:xfrm>
-            <a:off x="731520" y="2743200"/>
-            <a:ext cx="10725912" cy="0"/>
+            <a:off x="731520" y="2286000"/>
+            <a:ext cx="3108960" cy="0"/>
           </a:xfrm>
           <a:prstGeom prst="line">
             <a:avLst/>
@@ -4162,33 +4251,352 @@
       </p:sp>
       <p:sp>
         <p:nvSpPr>
-          <p:cNvPr id="7" name="Shape 5"/>
-          <p:cNvSpPr/>
-          <p:nvPr/>
-        </p:nvSpPr>
-        <p:spPr>
-          <a:xfrm>
-            <a:off x="731520" y="3017520"/>
-            <a:ext cx="5303520" cy="2926080"/>
+          <p:cNvPr id="7" name="Text 5"/>
+          <p:cNvSpPr/>
+          <p:nvPr/>
+        </p:nvSpPr>
+        <p:spPr>
+          <a:xfrm>
+            <a:off x="731520" y="2377440"/>
+            <a:ext cx="3108960" cy="274320"/>
+          </a:xfrm>
+          <a:prstGeom prst="rect">
+            <a:avLst/>
+          </a:prstGeom>
+          <a:noFill/>
+          <a:ln/>
+        </p:spPr>
+        <p:txBody>
+          <a:bodyPr wrap="square" rtlCol="0" anchor="ctr"/>
+          <a:lstStyle/>
+          <a:p>
+            <a:pPr indent="0" marL="0">
+              <a:buNone/>
+            </a:pPr>
+            <a:r>
+              <a:rPr lang="en-US" sz="1100" b="1" dirty="0">
+                <a:solidFill>
+                  <a:srgbClr val="5F6F68"/>
+                </a:solidFill>
+                <a:latin typeface="Arial" pitchFamily="34" charset="0"/>
+                <a:ea typeface="Arial" pitchFamily="34" charset="-122"/>
+                <a:cs typeface="Arial" pitchFamily="34" charset="-120"/>
+              </a:rPr>
+              <a:t>WHO</a:t>
+            </a:r>
+            <a:endParaRPr lang="en-US" sz="1100" dirty="0"/>
+          </a:p>
+        </p:txBody>
+      </p:sp>
+      <p:sp>
+        <p:nvSpPr>
+          <p:cNvPr id="8" name="Text 6"/>
+          <p:cNvSpPr/>
+          <p:nvPr/>
+        </p:nvSpPr>
+        <p:spPr>
+          <a:xfrm>
+            <a:off x="731520" y="2697480"/>
+            <a:ext cx="3108960" cy="548640"/>
+          </a:xfrm>
+          <a:prstGeom prst="rect">
+            <a:avLst/>
+          </a:prstGeom>
+          <a:noFill/>
+          <a:ln/>
+        </p:spPr>
+        <p:txBody>
+          <a:bodyPr wrap="square" rtlCol="0" anchor="ctr"/>
+          <a:lstStyle/>
+          <a:p>
+            <a:pPr indent="0" marL="0">
+              <a:buNone/>
+            </a:pPr>
+            <a:r>
+              <a:rPr lang="en-US" sz="2000" b="1" dirty="0">
+                <a:solidFill>
+                  <a:srgbClr val="0F1F1A"/>
+                </a:solidFill>
+                <a:latin typeface="Arial" pitchFamily="34" charset="0"/>
+                <a:ea typeface="Arial" pitchFamily="34" charset="-122"/>
+                <a:cs typeface="Arial" pitchFamily="34" charset="-120"/>
+              </a:rPr>
+              <a:t>Fresh IT graduates</a:t>
+            </a:r>
+            <a:endParaRPr lang="en-US" sz="2000" dirty="0"/>
+          </a:p>
+        </p:txBody>
+      </p:sp>
+      <p:sp>
+        <p:nvSpPr>
+          <p:cNvPr id="9" name="Shape 7"/>
+          <p:cNvSpPr/>
+          <p:nvPr/>
+        </p:nvSpPr>
+        <p:spPr>
+          <a:xfrm>
+            <a:off x="731520" y="3520440"/>
+            <a:ext cx="3108960" cy="0"/>
+          </a:xfrm>
+          <a:prstGeom prst="line">
+            <a:avLst/>
+          </a:prstGeom>
+          <a:noFill/>
+          <a:ln w="19050">
+            <a:solidFill>
+              <a:srgbClr val="CBD5D0"/>
+            </a:solidFill>
+            <a:prstDash val="solid"/>
+          </a:ln>
+        </p:spPr>
+      </p:sp>
+      <p:sp>
+        <p:nvSpPr>
+          <p:cNvPr id="10" name="Text 8"/>
+          <p:cNvSpPr/>
+          <p:nvPr/>
+        </p:nvSpPr>
+        <p:spPr>
+          <a:xfrm>
+            <a:off x="731520" y="3611880"/>
+            <a:ext cx="3108960" cy="274320"/>
+          </a:xfrm>
+          <a:prstGeom prst="rect">
+            <a:avLst/>
+          </a:prstGeom>
+          <a:noFill/>
+          <a:ln/>
+        </p:spPr>
+        <p:txBody>
+          <a:bodyPr wrap="square" rtlCol="0" anchor="ctr"/>
+          <a:lstStyle/>
+          <a:p>
+            <a:pPr indent="0" marL="0">
+              <a:buNone/>
+            </a:pPr>
+            <a:r>
+              <a:rPr lang="en-US" sz="1100" b="1" dirty="0">
+                <a:solidFill>
+                  <a:srgbClr val="5F6F68"/>
+                </a:solidFill>
+                <a:latin typeface="Arial" pitchFamily="34" charset="0"/>
+                <a:ea typeface="Arial" pitchFamily="34" charset="-122"/>
+                <a:cs typeface="Arial" pitchFamily="34" charset="-120"/>
+              </a:rPr>
+              <a:t>JORDAN FIRST</a:t>
+            </a:r>
+            <a:endParaRPr lang="en-US" sz="1100" dirty="0"/>
+          </a:p>
+        </p:txBody>
+      </p:sp>
+      <p:sp>
+        <p:nvSpPr>
+          <p:cNvPr id="11" name="Text 9"/>
+          <p:cNvSpPr/>
+          <p:nvPr/>
+        </p:nvSpPr>
+        <p:spPr>
+          <a:xfrm>
+            <a:off x="731520" y="3931920"/>
+            <a:ext cx="3108960" cy="548640"/>
+          </a:xfrm>
+          <a:prstGeom prst="rect">
+            <a:avLst/>
+          </a:prstGeom>
+          <a:noFill/>
+          <a:ln/>
+        </p:spPr>
+        <p:txBody>
+          <a:bodyPr wrap="square" rtlCol="0" anchor="ctr"/>
+          <a:lstStyle/>
+          <a:p>
+            <a:pPr indent="0" marL="0">
+              <a:buNone/>
+            </a:pPr>
+            <a:r>
+              <a:rPr lang="en-US" sz="2000" b="1" dirty="0">
+                <a:solidFill>
+                  <a:srgbClr val="0F9F6E"/>
+                </a:solidFill>
+                <a:latin typeface="Arial" pitchFamily="34" charset="0"/>
+                <a:ea typeface="Arial" pitchFamily="34" charset="-122"/>
+                <a:cs typeface="Arial" pitchFamily="34" charset="-120"/>
+              </a:rPr>
+              <a:t>[# of them in Jordan]</a:t>
+            </a:r>
+            <a:endParaRPr lang="en-US" sz="2000" dirty="0"/>
+          </a:p>
+        </p:txBody>
+      </p:sp>
+      <p:sp>
+        <p:nvSpPr>
+          <p:cNvPr id="12" name="Shape 10"/>
+          <p:cNvSpPr/>
+          <p:nvPr/>
+        </p:nvSpPr>
+        <p:spPr>
+          <a:xfrm>
+            <a:off x="731520" y="4754880"/>
+            <a:ext cx="3108960" cy="0"/>
+          </a:xfrm>
+          <a:prstGeom prst="line">
+            <a:avLst/>
+          </a:prstGeom>
+          <a:noFill/>
+          <a:ln w="19050">
+            <a:solidFill>
+              <a:srgbClr val="CBD5D0"/>
+            </a:solidFill>
+            <a:prstDash val="solid"/>
+          </a:ln>
+        </p:spPr>
+      </p:sp>
+      <p:sp>
+        <p:nvSpPr>
+          <p:cNvPr id="13" name="Text 11"/>
+          <p:cNvSpPr/>
+          <p:nvPr/>
+        </p:nvSpPr>
+        <p:spPr>
+          <a:xfrm>
+            <a:off x="731520" y="4846320"/>
+            <a:ext cx="3108960" cy="274320"/>
+          </a:xfrm>
+          <a:prstGeom prst="rect">
+            <a:avLst/>
+          </a:prstGeom>
+          <a:noFill/>
+          <a:ln/>
+        </p:spPr>
+        <p:txBody>
+          <a:bodyPr wrap="square" rtlCol="0" anchor="ctr"/>
+          <a:lstStyle/>
+          <a:p>
+            <a:pPr indent="0" marL="0">
+              <a:buNone/>
+            </a:pPr>
+            <a:r>
+              <a:rPr lang="en-US" sz="1100" b="1" dirty="0">
+                <a:solidFill>
+                  <a:srgbClr val="5F6F68"/>
+                </a:solidFill>
+                <a:latin typeface="Arial" pitchFamily="34" charset="0"/>
+                <a:ea typeface="Arial" pitchFamily="34" charset="-122"/>
+                <a:cs typeface="Arial" pitchFamily="34" charset="-120"/>
+              </a:rPr>
+              <a:t>MENA NEXT</a:t>
+            </a:r>
+            <a:endParaRPr lang="en-US" sz="1100" dirty="0"/>
+          </a:p>
+        </p:txBody>
+      </p:sp>
+      <p:sp>
+        <p:nvSpPr>
+          <p:cNvPr id="14" name="Text 12"/>
+          <p:cNvSpPr/>
+          <p:nvPr/>
+        </p:nvSpPr>
+        <p:spPr>
+          <a:xfrm>
+            <a:off x="731520" y="5166360"/>
+            <a:ext cx="3108960" cy="548640"/>
+          </a:xfrm>
+          <a:prstGeom prst="rect">
+            <a:avLst/>
+          </a:prstGeom>
+          <a:noFill/>
+          <a:ln/>
+        </p:spPr>
+        <p:txBody>
+          <a:bodyPr wrap="square" rtlCol="0" anchor="ctr"/>
+          <a:lstStyle/>
+          <a:p>
+            <a:pPr indent="0" marL="0">
+              <a:buNone/>
+            </a:pPr>
+            <a:r>
+              <a:rPr lang="en-US" sz="2000" b="1" dirty="0">
+                <a:solidFill>
+                  <a:srgbClr val="0F9F6E"/>
+                </a:solidFill>
+                <a:latin typeface="Arial" pitchFamily="34" charset="0"/>
+                <a:ea typeface="Arial" pitchFamily="34" charset="-122"/>
+                <a:cs typeface="Arial" pitchFamily="34" charset="-120"/>
+              </a:rPr>
+              <a:t>[# of them in MENA]</a:t>
+            </a:r>
+            <a:endParaRPr lang="en-US" sz="2000" dirty="0"/>
+          </a:p>
+        </p:txBody>
+      </p:sp>
+      <p:sp>
+        <p:nvSpPr>
+          <p:cNvPr id="15" name="Text 13"/>
+          <p:cNvSpPr/>
+          <p:nvPr/>
+        </p:nvSpPr>
+        <p:spPr>
+          <a:xfrm>
+            <a:off x="4297680" y="1371600"/>
+            <a:ext cx="7132320" cy="274320"/>
+          </a:xfrm>
+          <a:prstGeom prst="rect">
+            <a:avLst/>
+          </a:prstGeom>
+          <a:noFill/>
+          <a:ln/>
+        </p:spPr>
+        <p:txBody>
+          <a:bodyPr wrap="square" rtlCol="0" anchor="ctr"/>
+          <a:lstStyle/>
+          <a:p>
+            <a:pPr indent="0" marL="0">
+              <a:buNone/>
+            </a:pPr>
+            <a:r>
+              <a:rPr lang="en-US" sz="1000" dirty="0">
+                <a:solidFill>
+                  <a:srgbClr val="5F6F68"/>
+                </a:solidFill>
+                <a:latin typeface="Arial" pitchFamily="34" charset="0"/>
+                <a:ea typeface="Arial" pitchFamily="34" charset="-122"/>
+                <a:cs typeface="Arial" pitchFamily="34" charset="-120"/>
+              </a:rPr>
+              <a:t>↑ CONVERSATIONAL AI ASSESSMENT</a:t>
+            </a:r>
+            <a:endParaRPr lang="en-US" sz="1000" dirty="0"/>
+          </a:p>
+        </p:txBody>
+      </p:sp>
+      <p:sp>
+        <p:nvSpPr>
+          <p:cNvPr id="16" name="Shape 14"/>
+          <p:cNvSpPr/>
+          <p:nvPr/>
+        </p:nvSpPr>
+        <p:spPr>
+          <a:xfrm>
+            <a:off x="4297680" y="1783080"/>
+            <a:ext cx="7159752" cy="4069080"/>
           </a:xfrm>
           <a:prstGeom prst="roundRect">
             <a:avLst>
-              <a:gd name="adj" fmla="val 6250"/>
+              <a:gd name="adj" fmla="val 3371"/>
             </a:avLst>
           </a:prstGeom>
           <a:solidFill>
             <a:srgbClr val="FFFFFF"/>
           </a:solidFill>
-          <a:ln w="12700">
+          <a:ln w="19050">
             <a:solidFill>
-              <a:srgbClr val="E3E9E6"/>
+              <a:srgbClr val="CBD5D0"/>
             </a:solidFill>
             <a:prstDash val="solid"/>
           </a:ln>
           <a:effectLst>
             <a:outerShdw sx="100000" sy="100000" kx="0" ky="0" algn="bl" rotWithShape="0" blurRad="127000" dist="38100" dir="5400000">
               <a:srgbClr val="103020">
-                <a:alpha val="12000"/>
+                <a:alpha val="10000"/>
               </a:srgbClr>
             </a:outerShdw>
           </a:effectLst>
@@ -4196,308 +4604,301 @@
       </p:sp>
       <p:sp>
         <p:nvSpPr>
-          <p:cNvPr id="8" name="Text 6"/>
-          <p:cNvSpPr/>
-          <p:nvPr/>
-        </p:nvSpPr>
-        <p:spPr>
-          <a:xfrm>
-            <a:off x="1005840" y="3246120"/>
-            <a:ext cx="4754880" cy="274320"/>
-          </a:xfrm>
-          <a:prstGeom prst="rect">
-            <a:avLst/>
-          </a:prstGeom>
-          <a:noFill/>
-          <a:ln/>
-        </p:spPr>
-        <p:txBody>
-          <a:bodyPr wrap="square" rtlCol="0" anchor="ctr"/>
-          <a:lstStyle/>
-          <a:p>
-            <a:pPr indent="0" marL="0">
-              <a:buNone/>
-            </a:pPr>
-            <a:r>
-              <a:rPr lang="en-US" sz="1100" b="1" dirty="0">
-                <a:solidFill>
-                  <a:srgbClr val="0F9F6E"/>
-                </a:solidFill>
-                <a:latin typeface="Arial" pitchFamily="34" charset="0"/>
-                <a:ea typeface="Arial" pitchFamily="34" charset="-122"/>
-                <a:cs typeface="Arial" pitchFamily="34" charset="-120"/>
-              </a:rPr>
-              <a:t>BASIC</a:t>
-            </a:r>
-            <a:endParaRPr lang="en-US" sz="1100" dirty="0"/>
-          </a:p>
-        </p:txBody>
-      </p:sp>
-      <p:sp>
-        <p:nvSpPr>
-          <p:cNvPr id="9" name="Text 7"/>
-          <p:cNvSpPr/>
-          <p:nvPr/>
-        </p:nvSpPr>
-        <p:spPr>
-          <a:xfrm>
-            <a:off x="1005840" y="3566160"/>
-            <a:ext cx="4754880" cy="548640"/>
-          </a:xfrm>
-          <a:prstGeom prst="rect">
-            <a:avLst/>
-          </a:prstGeom>
-          <a:noFill/>
-          <a:ln/>
-        </p:spPr>
-        <p:txBody>
-          <a:bodyPr wrap="square" rtlCol="0" anchor="ctr"/>
-          <a:lstStyle/>
-          <a:p>
-            <a:pPr indent="0" marL="0">
-              <a:buNone/>
-            </a:pPr>
-            <a:r>
-              <a:rPr lang="en-US" sz="2400" b="1" dirty="0">
-                <a:solidFill>
-                  <a:srgbClr val="0F1F1A"/>
-                </a:solidFill>
-                <a:latin typeface="Arial" pitchFamily="34" charset="0"/>
-                <a:ea typeface="Arial" pitchFamily="34" charset="-122"/>
-                <a:cs typeface="Arial" pitchFamily="34" charset="-120"/>
-              </a:rPr>
-              <a:t>10 JOD / month</a:t>
-            </a:r>
-            <a:endParaRPr lang="en-US" sz="2400" dirty="0"/>
-          </a:p>
-        </p:txBody>
-      </p:sp>
-      <p:sp>
-        <p:nvSpPr>
-          <p:cNvPr id="10" name="Text 8"/>
-          <p:cNvSpPr/>
-          <p:nvPr/>
-        </p:nvSpPr>
-        <p:spPr>
-          <a:xfrm>
-            <a:off x="1005840" y="4160520"/>
-            <a:ext cx="4754880" cy="1645920"/>
-          </a:xfrm>
-          <a:prstGeom prst="rect">
-            <a:avLst/>
-          </a:prstGeom>
-          <a:noFill/>
-          <a:ln/>
-        </p:spPr>
-        <p:txBody>
-          <a:bodyPr wrap="square" rtlCol="0" anchor="t"/>
-          <a:lstStyle/>
-          <a:p>
-            <a:pPr indent="0" marL="0">
-              <a:buNone/>
-            </a:pPr>
-            <a:r>
-              <a:rPr lang="en-US" sz="1800" dirty="0">
-                <a:solidFill>
-                  <a:srgbClr val="222222"/>
-                </a:solidFill>
-                <a:latin typeface="Arial" pitchFamily="34" charset="0"/>
-                <a:ea typeface="Arial" pitchFamily="34" charset="-122"/>
-                <a:cs typeface="Arial" pitchFamily="34" charset="-120"/>
-              </a:rPr>
-              <a:t>Browse and filter candidates. Limited invites.</a:t>
-            </a:r>
-            <a:endParaRPr lang="en-US" sz="1800" dirty="0"/>
-          </a:p>
-        </p:txBody>
-      </p:sp>
-      <p:sp>
-        <p:nvSpPr>
-          <p:cNvPr id="11" name="Shape 9"/>
-          <p:cNvSpPr/>
-          <p:nvPr/>
-        </p:nvSpPr>
-        <p:spPr>
-          <a:xfrm>
-            <a:off x="6153912" y="3017520"/>
-            <a:ext cx="5303520" cy="2926080"/>
+          <p:cNvPr id="17" name="Shape 15"/>
+          <p:cNvSpPr/>
+          <p:nvPr/>
+        </p:nvSpPr>
+        <p:spPr>
+          <a:xfrm>
+            <a:off x="7877556" y="1783080"/>
+            <a:ext cx="0" cy="4069080"/>
+          </a:xfrm>
+          <a:prstGeom prst="line">
+            <a:avLst/>
+          </a:prstGeom>
+          <a:noFill/>
+          <a:ln w="12700">
+            <a:solidFill>
+              <a:srgbClr val="CBD5D0"/>
+            </a:solidFill>
+            <a:prstDash val="dash"/>
+          </a:ln>
+        </p:spPr>
+      </p:sp>
+      <p:sp>
+        <p:nvSpPr>
+          <p:cNvPr id="18" name="Shape 16"/>
+          <p:cNvSpPr/>
+          <p:nvPr/>
+        </p:nvSpPr>
+        <p:spPr>
+          <a:xfrm>
+            <a:off x="4297680" y="3817620"/>
+            <a:ext cx="7159752" cy="0"/>
+          </a:xfrm>
+          <a:prstGeom prst="line">
+            <a:avLst/>
+          </a:prstGeom>
+          <a:noFill/>
+          <a:ln w="12700">
+            <a:solidFill>
+              <a:srgbClr val="CBD5D0"/>
+            </a:solidFill>
+            <a:prstDash val="dash"/>
+          </a:ln>
+        </p:spPr>
+      </p:sp>
+      <p:sp>
+        <p:nvSpPr>
+          <p:cNvPr id="19" name="Text 17"/>
+          <p:cNvSpPr/>
+          <p:nvPr/>
+        </p:nvSpPr>
+        <p:spPr>
+          <a:xfrm>
+            <a:off x="4937760" y="2468880"/>
+            <a:ext cx="1737360" cy="411480"/>
           </a:xfrm>
           <a:prstGeom prst="roundRect">
             <a:avLst>
-              <a:gd name="adj" fmla="val 6250"/>
+              <a:gd name="adj" fmla="val 26667"/>
             </a:avLst>
           </a:prstGeom>
           <a:solidFill>
-            <a:srgbClr val="FFFFFF"/>
+            <a:srgbClr val="EEF2F0"/>
           </a:solidFill>
-          <a:ln w="25400">
-            <a:solidFill>
-              <a:srgbClr val="0F9F6E"/>
-            </a:solidFill>
-            <a:prstDash val="solid"/>
-          </a:ln>
-          <a:effectLst>
-            <a:outerShdw sx="100000" sy="100000" kx="0" ky="0" algn="bl" rotWithShape="0" blurRad="127000" dist="38100" dir="5400000">
-              <a:srgbClr val="103020">
-                <a:alpha val="12000"/>
-              </a:srgbClr>
-            </a:outerShdw>
-          </a:effectLst>
-        </p:spPr>
-      </p:sp>
-      <p:sp>
-        <p:nvSpPr>
-          <p:cNvPr id="12" name="Text 10"/>
-          <p:cNvSpPr/>
-          <p:nvPr/>
-        </p:nvSpPr>
-        <p:spPr>
-          <a:xfrm>
-            <a:off x="6428232" y="3246120"/>
-            <a:ext cx="4754880" cy="274320"/>
-          </a:xfrm>
-          <a:prstGeom prst="rect">
-            <a:avLst/>
-          </a:prstGeom>
-          <a:noFill/>
-          <a:ln/>
-        </p:spPr>
-        <p:txBody>
-          <a:bodyPr wrap="square" rtlCol="0" anchor="ctr"/>
-          <a:lstStyle/>
-          <a:p>
-            <a:pPr indent="0" marL="0">
+          <a:ln/>
+        </p:spPr>
+        <p:txBody>
+          <a:bodyPr wrap="square" rtlCol="0" anchor="ctr"/>
+          <a:lstStyle/>
+          <a:p>
+            <a:pPr algn="ctr" indent="0" marL="0">
+              <a:buNone/>
+            </a:pPr>
+            <a:r>
+              <a:rPr lang="en-US" sz="1200" b="1" dirty="0">
+                <a:solidFill>
+                  <a:srgbClr val="333333"/>
+                </a:solidFill>
+                <a:latin typeface="Arial" pitchFamily="34" charset="0"/>
+                <a:ea typeface="Arial" pitchFamily="34" charset="-122"/>
+                <a:cs typeface="Arial" pitchFamily="34" charset="-120"/>
+              </a:rPr>
+              <a:t>[COMPETITOR B]</a:t>
+            </a:r>
+            <a:endParaRPr lang="en-US" sz="1200" dirty="0"/>
+          </a:p>
+        </p:txBody>
+      </p:sp>
+      <p:sp>
+        <p:nvSpPr>
+          <p:cNvPr id="20" name="Text 18"/>
+          <p:cNvSpPr/>
+          <p:nvPr/>
+        </p:nvSpPr>
+        <p:spPr>
+          <a:xfrm>
+            <a:off x="9144000" y="2468880"/>
+            <a:ext cx="1737360" cy="411480"/>
+          </a:xfrm>
+          <a:prstGeom prst="roundRect">
+            <a:avLst>
+              <a:gd name="adj" fmla="val 26667"/>
+            </a:avLst>
+          </a:prstGeom>
+          <a:solidFill>
+            <a:srgbClr val="0F9F6E"/>
+          </a:solidFill>
+          <a:ln/>
+        </p:spPr>
+        <p:txBody>
+          <a:bodyPr wrap="square" rtlCol="0" anchor="ctr"/>
+          <a:lstStyle/>
+          <a:p>
+            <a:pPr algn="ctr" indent="0" marL="0">
+              <a:buNone/>
+            </a:pPr>
+            <a:r>
+              <a:rPr lang="en-US" sz="1200" b="1" dirty="0">
+                <a:solidFill>
+                  <a:srgbClr val="FFFFFF"/>
+                </a:solidFill>
+                <a:latin typeface="Arial" pitchFamily="34" charset="0"/>
+                <a:ea typeface="Arial" pitchFamily="34" charset="-122"/>
+                <a:cs typeface="Arial" pitchFamily="34" charset="-120"/>
+              </a:rPr>
+              <a:t>MISH SENIOR</a:t>
+            </a:r>
+            <a:endParaRPr lang="en-US" sz="1200" dirty="0"/>
+          </a:p>
+        </p:txBody>
+      </p:sp>
+      <p:sp>
+        <p:nvSpPr>
+          <p:cNvPr id="21" name="Text 19"/>
+          <p:cNvSpPr/>
+          <p:nvPr/>
+        </p:nvSpPr>
+        <p:spPr>
+          <a:xfrm>
+            <a:off x="4937760" y="4754880"/>
+            <a:ext cx="1737360" cy="411480"/>
+          </a:xfrm>
+          <a:prstGeom prst="roundRect">
+            <a:avLst>
+              <a:gd name="adj" fmla="val 26667"/>
+            </a:avLst>
+          </a:prstGeom>
+          <a:solidFill>
+            <a:srgbClr val="EEF2F0"/>
+          </a:solidFill>
+          <a:ln/>
+        </p:spPr>
+        <p:txBody>
+          <a:bodyPr wrap="square" rtlCol="0" anchor="ctr"/>
+          <a:lstStyle/>
+          <a:p>
+            <a:pPr algn="ctr" indent="0" marL="0">
+              <a:buNone/>
+            </a:pPr>
+            <a:r>
+              <a:rPr lang="en-US" sz="1200" b="1" dirty="0">
+                <a:solidFill>
+                  <a:srgbClr val="333333"/>
+                </a:solidFill>
+                <a:latin typeface="Arial" pitchFamily="34" charset="0"/>
+                <a:ea typeface="Arial" pitchFamily="34" charset="-122"/>
+                <a:cs typeface="Arial" pitchFamily="34" charset="-120"/>
+              </a:rPr>
+              <a:t>TURING</a:t>
+            </a:r>
+            <a:endParaRPr lang="en-US" sz="1200" dirty="0"/>
+          </a:p>
+        </p:txBody>
+      </p:sp>
+      <p:sp>
+        <p:nvSpPr>
+          <p:cNvPr id="22" name="Text 20"/>
+          <p:cNvSpPr/>
+          <p:nvPr/>
+        </p:nvSpPr>
+        <p:spPr>
+          <a:xfrm>
+            <a:off x="9144000" y="4754880"/>
+            <a:ext cx="1737360" cy="411480"/>
+          </a:xfrm>
+          <a:prstGeom prst="roundRect">
+            <a:avLst>
+              <a:gd name="adj" fmla="val 26667"/>
+            </a:avLst>
+          </a:prstGeom>
+          <a:solidFill>
+            <a:srgbClr val="EEF2F0"/>
+          </a:solidFill>
+          <a:ln/>
+        </p:spPr>
+        <p:txBody>
+          <a:bodyPr wrap="square" rtlCol="0" anchor="ctr"/>
+          <a:lstStyle/>
+          <a:p>
+            <a:pPr algn="ctr" indent="0" marL="0">
+              <a:buNone/>
+            </a:pPr>
+            <a:r>
+              <a:rPr lang="en-US" sz="1200" b="1" dirty="0">
+                <a:solidFill>
+                  <a:srgbClr val="333333"/>
+                </a:solidFill>
+                <a:latin typeface="Arial" pitchFamily="34" charset="0"/>
+                <a:ea typeface="Arial" pitchFamily="34" charset="-122"/>
+                <a:cs typeface="Arial" pitchFamily="34" charset="-120"/>
+              </a:rPr>
+              <a:t>[COMPETITOR C]</a:t>
+            </a:r>
+            <a:endParaRPr lang="en-US" sz="1200" dirty="0"/>
+          </a:p>
+        </p:txBody>
+      </p:sp>
+      <p:sp>
+        <p:nvSpPr>
+          <p:cNvPr id="23" name="Text 21"/>
+          <p:cNvSpPr/>
+          <p:nvPr/>
+        </p:nvSpPr>
+        <p:spPr>
+          <a:xfrm>
+            <a:off x="4297680" y="5943600"/>
+            <a:ext cx="7159752" cy="274320"/>
+          </a:xfrm>
+          <a:prstGeom prst="rect">
+            <a:avLst/>
+          </a:prstGeom>
+          <a:noFill/>
+          <a:ln/>
+        </p:spPr>
+        <p:txBody>
+          <a:bodyPr wrap="square" rtlCol="0" anchor="ctr"/>
+          <a:lstStyle/>
+          <a:p>
+            <a:pPr algn="ctr" indent="0" marL="0">
+              <a:buNone/>
+            </a:pPr>
+            <a:r>
+              <a:rPr lang="en-US" sz="1000" dirty="0">
+                <a:solidFill>
+                  <a:srgbClr val="5F6F68"/>
+                </a:solidFill>
+                <a:latin typeface="Arial" pitchFamily="34" charset="0"/>
+                <a:ea typeface="Arial" pitchFamily="34" charset="-122"/>
+                <a:cs typeface="Arial" pitchFamily="34" charset="-120"/>
+              </a:rPr>
+              <a:t>← SENIORS ONLY          FOR FRESH GRADUATES →</a:t>
+            </a:r>
+            <a:endParaRPr lang="en-US" sz="1000" dirty="0"/>
+          </a:p>
+        </p:txBody>
+      </p:sp>
+      <p:sp>
+        <p:nvSpPr>
+          <p:cNvPr id="24" name="Text 22"/>
+          <p:cNvSpPr/>
+          <p:nvPr/>
+        </p:nvSpPr>
+        <p:spPr>
+          <a:xfrm>
+            <a:off x="10332720" y="640080"/>
+            <a:ext cx="1097280" cy="365760"/>
+          </a:xfrm>
+          <a:prstGeom prst="roundRect">
+            <a:avLst>
+              <a:gd name="adj" fmla="val 25000"/>
+            </a:avLst>
+          </a:prstGeom>
+          <a:solidFill>
+            <a:srgbClr val="0F1F1A"/>
+          </a:solidFill>
+          <a:ln/>
+        </p:spPr>
+        <p:txBody>
+          <a:bodyPr wrap="square" rtlCol="0" anchor="ctr"/>
+          <a:lstStyle/>
+          <a:p>
+            <a:pPr algn="ctr" indent="0" marL="0">
               <a:buNone/>
             </a:pPr>
             <a:r>
               <a:rPr lang="en-US" sz="1100" b="1" dirty="0">
                 <a:solidFill>
-                  <a:srgbClr val="0F9F6E"/>
-                </a:solidFill>
-                <a:latin typeface="Arial" pitchFamily="34" charset="0"/>
-                <a:ea typeface="Arial" pitchFamily="34" charset="-122"/>
-                <a:cs typeface="Arial" pitchFamily="34" charset="-120"/>
-              </a:rPr>
-              <a:t>PREMIUM</a:t>
+                  <a:srgbClr val="FFFFFF"/>
+                </a:solidFill>
+                <a:latin typeface="Arial" pitchFamily="34" charset="0"/>
+                <a:ea typeface="Arial" pitchFamily="34" charset="-122"/>
+                <a:cs typeface="Arial" pitchFamily="34" charset="-120"/>
+              </a:rPr>
+              <a:t>15 SEC</a:t>
             </a:r>
             <a:endParaRPr lang="en-US" sz="1100" dirty="0"/>
-          </a:p>
-        </p:txBody>
-      </p:sp>
-      <p:sp>
-        <p:nvSpPr>
-          <p:cNvPr id="13" name="Text 11"/>
-          <p:cNvSpPr/>
-          <p:nvPr/>
-        </p:nvSpPr>
-        <p:spPr>
-          <a:xfrm>
-            <a:off x="6428232" y="3566160"/>
-            <a:ext cx="4754880" cy="548640"/>
-          </a:xfrm>
-          <a:prstGeom prst="rect">
-            <a:avLst/>
-          </a:prstGeom>
-          <a:noFill/>
-          <a:ln/>
-        </p:spPr>
-        <p:txBody>
-          <a:bodyPr wrap="square" rtlCol="0" anchor="ctr"/>
-          <a:lstStyle/>
-          <a:p>
-            <a:pPr indent="0" marL="0">
-              <a:buNone/>
-            </a:pPr>
-            <a:r>
-              <a:rPr lang="en-US" sz="2400" b="1" dirty="0">
-                <a:solidFill>
-                  <a:srgbClr val="0F1F1A"/>
-                </a:solidFill>
-                <a:latin typeface="Arial" pitchFamily="34" charset="0"/>
-                <a:ea typeface="Arial" pitchFamily="34" charset="-122"/>
-                <a:cs typeface="Arial" pitchFamily="34" charset="-120"/>
-              </a:rPr>
-              <a:t>25 JOD / month</a:t>
-            </a:r>
-            <a:endParaRPr lang="en-US" sz="2400" dirty="0"/>
-          </a:p>
-        </p:txBody>
-      </p:sp>
-      <p:sp>
-        <p:nvSpPr>
-          <p:cNvPr id="14" name="Text 12"/>
-          <p:cNvSpPr/>
-          <p:nvPr/>
-        </p:nvSpPr>
-        <p:spPr>
-          <a:xfrm>
-            <a:off x="6428232" y="4160520"/>
-            <a:ext cx="4754880" cy="1645920"/>
-          </a:xfrm>
-          <a:prstGeom prst="rect">
-            <a:avLst/>
-          </a:prstGeom>
-          <a:noFill/>
-          <a:ln/>
-        </p:spPr>
-        <p:txBody>
-          <a:bodyPr wrap="square" rtlCol="0" anchor="t"/>
-          <a:lstStyle/>
-          <a:p>
-            <a:pPr indent="0" marL="0">
-              <a:buNone/>
-            </a:pPr>
-            <a:r>
-              <a:rPr lang="en-US" sz="1800" dirty="0">
-                <a:solidFill>
-                  <a:srgbClr val="222222"/>
-                </a:solidFill>
-                <a:latin typeface="Arial" pitchFamily="34" charset="0"/>
-                <a:ea typeface="Arial" pitchFamily="34" charset="-122"/>
-                <a:cs typeface="Arial" pitchFamily="34" charset="-120"/>
-              </a:rPr>
-              <a:t>Unlimited invites. Priority access to new candidates.</a:t>
-            </a:r>
-            <a:endParaRPr lang="en-US" sz="1800" dirty="0"/>
-          </a:p>
-        </p:txBody>
-      </p:sp>
-      <p:sp>
-        <p:nvSpPr>
-          <p:cNvPr id="15" name="Text 13"/>
-          <p:cNvSpPr/>
-          <p:nvPr/>
-        </p:nvSpPr>
-        <p:spPr>
-          <a:xfrm>
-            <a:off x="731520" y="5989320"/>
-            <a:ext cx="7315200" cy="274320"/>
-          </a:xfrm>
-          <a:prstGeom prst="rect">
-            <a:avLst/>
-          </a:prstGeom>
-          <a:noFill/>
-          <a:ln/>
-        </p:spPr>
-        <p:txBody>
-          <a:bodyPr wrap="square" rtlCol="0" anchor="ctr"/>
-          <a:lstStyle/>
-          <a:p>
-            <a:pPr indent="0" marL="0">
-              <a:buNone/>
-            </a:pPr>
-            <a:r>
-              <a:rPr lang="en-US" sz="1000" dirty="0">
-                <a:solidFill>
-                  <a:srgbClr val="5F6F68"/>
-                </a:solidFill>
-                <a:latin typeface="Arial" pitchFamily="34" charset="0"/>
-                <a:ea typeface="Arial" pitchFamily="34" charset="-122"/>
-                <a:cs typeface="Arial" pitchFamily="34" charset="-120"/>
-              </a:rPr>
-              <a:t>Demo note: payments are simulated.</a:t>
-            </a:r>
-            <a:endParaRPr lang="en-US" sz="1000" dirty="0"/>
           </a:p>
         </p:txBody>
       </p:sp>
@@ -4570,7 +4971,7 @@
                 <a:ea typeface="Arial" pitchFamily="34" charset="-122"/>
                 <a:cs typeface="Arial" pitchFamily="34" charset="-120"/>
               </a:rPr>
-              <a:t>07 // TEAM · 10 SEC</a:t>
+              <a:t>06 // BUSINESS · 15 SEC</a:t>
             </a:r>
             <a:endParaRPr lang="en-US" sz="1200" dirty="0"/>
           </a:p>
@@ -4648,7 +5049,7 @@
                 <a:ea typeface="Arial" pitchFamily="34" charset="-122"/>
                 <a:cs typeface="Arial" pitchFamily="34" charset="-120"/>
               </a:rPr>
-              <a:t>07 / 08</a:t>
+              <a:t>07 / 09</a:t>
             </a:r>
             <a:endParaRPr lang="en-US" sz="1000" dirty="0"/>
           </a:p>
@@ -4687,7 +5088,7 @@
                 <a:ea typeface="Arial" pitchFamily="34" charset="-122"/>
                 <a:cs typeface="Arial" pitchFamily="34" charset="-120"/>
               </a:rPr>
-              <a:t>The team.</a:t>
+              <a:t>Companies pay. Graduates start free.</a:t>
             </a:r>
             <a:endParaRPr lang="en-US" sz="4400" dirty="0"/>
           </a:p>
@@ -4725,11 +5126,11 @@
         <p:spPr>
           <a:xfrm>
             <a:off x="731520" y="3017520"/>
-            <a:ext cx="3383280" cy="2377440"/>
+            <a:ext cx="5303520" cy="2926080"/>
           </a:xfrm>
           <a:prstGeom prst="roundRect">
             <a:avLst>
-              <a:gd name="adj" fmla="val 6923"/>
+              <a:gd name="adj" fmla="val 6250"/>
             </a:avLst>
           </a:prstGeom>
           <a:solidFill>
@@ -4758,8 +5159,8 @@
         </p:nvSpPr>
         <p:spPr>
           <a:xfrm>
-            <a:off x="1005840" y="3200400"/>
-            <a:ext cx="2834640" cy="274320"/>
+            <a:off x="1005840" y="3246120"/>
+            <a:ext cx="4754880" cy="274320"/>
           </a:xfrm>
           <a:prstGeom prst="rect">
             <a:avLst/>
@@ -4783,7 +5184,7 @@
                 <a:ea typeface="Arial" pitchFamily="34" charset="-122"/>
                 <a:cs typeface="Arial" pitchFamily="34" charset="-120"/>
               </a:rPr>
-              <a:t>ROLE</a:t>
+              <a:t>BASIC</a:t>
             </a:r>
             <a:endParaRPr lang="en-US" sz="1100" dirty="0"/>
           </a:p>
@@ -4797,8 +5198,8 @@
         </p:nvSpPr>
         <p:spPr>
           <a:xfrm>
-            <a:off x="1005840" y="3520440"/>
-            <a:ext cx="2834640" cy="548640"/>
+            <a:off x="1005840" y="3566160"/>
+            <a:ext cx="4754880" cy="548640"/>
           </a:xfrm>
           <a:prstGeom prst="rect">
             <a:avLst/>
@@ -4816,13 +5217,13 @@
             <a:r>
               <a:rPr lang="en-US" sz="2400" b="1" dirty="0">
                 <a:solidFill>
-                  <a:srgbClr val="0F9F6E"/>
-                </a:solidFill>
-                <a:latin typeface="Arial" pitchFamily="34" charset="0"/>
-                <a:ea typeface="Arial" pitchFamily="34" charset="-122"/>
-                <a:cs typeface="Arial" pitchFamily="34" charset="-120"/>
-              </a:rPr>
-              <a:t>[Name]</a:t>
+                  <a:srgbClr val="0F1F1A"/>
+                </a:solidFill>
+                <a:latin typeface="Arial" pitchFamily="34" charset="0"/>
+                <a:ea typeface="Arial" pitchFamily="34" charset="-122"/>
+                <a:cs typeface="Arial" pitchFamily="34" charset="-120"/>
+              </a:rPr>
+              <a:t>10 JOD / month</a:t>
             </a:r>
             <a:endParaRPr lang="en-US" sz="2400" dirty="0"/>
           </a:p>
@@ -4836,8 +5237,8 @@
         </p:nvSpPr>
         <p:spPr>
           <a:xfrm>
-            <a:off x="1005840" y="4114800"/>
-            <a:ext cx="2834640" cy="1097280"/>
+            <a:off x="1005840" y="4160520"/>
+            <a:ext cx="4754880" cy="1645920"/>
           </a:xfrm>
           <a:prstGeom prst="rect">
             <a:avLst/>
@@ -4853,17 +5254,17 @@
               <a:buNone/>
             </a:pPr>
             <a:r>
-              <a:rPr lang="en-US" sz="1700" dirty="0">
-                <a:solidFill>
-                  <a:srgbClr val="333333"/>
-                </a:solidFill>
-                <a:latin typeface="Arial" pitchFamily="34" charset="0"/>
-                <a:ea typeface="Arial" pitchFamily="34" charset="-122"/>
-                <a:cs typeface="Arial" pitchFamily="34" charset="-120"/>
-              </a:rPr>
-              <a:t>[Role]</a:t>
-            </a:r>
-            <a:endParaRPr lang="en-US" sz="1700" dirty="0"/>
+              <a:rPr lang="en-US" sz="1800" dirty="0">
+                <a:solidFill>
+                  <a:srgbClr val="222222"/>
+                </a:solidFill>
+                <a:latin typeface="Arial" pitchFamily="34" charset="0"/>
+                <a:ea typeface="Arial" pitchFamily="34" charset="-122"/>
+                <a:cs typeface="Arial" pitchFamily="34" charset="-120"/>
+              </a:rPr>
+              <a:t>Browse and filter candidates. Limited invites.</a:t>
+            </a:r>
+            <a:endParaRPr lang="en-US" sz="1800" dirty="0"/>
           </a:p>
         </p:txBody>
       </p:sp>
@@ -4875,20 +5276,20 @@
         </p:nvSpPr>
         <p:spPr>
           <a:xfrm>
-            <a:off x="4389120" y="3017520"/>
-            <a:ext cx="3383280" cy="2377440"/>
+            <a:off x="6153912" y="3017520"/>
+            <a:ext cx="5303520" cy="2926080"/>
           </a:xfrm>
           <a:prstGeom prst="roundRect">
             <a:avLst>
-              <a:gd name="adj" fmla="val 6923"/>
+              <a:gd name="adj" fmla="val 6250"/>
             </a:avLst>
           </a:prstGeom>
           <a:solidFill>
             <a:srgbClr val="FFFFFF"/>
           </a:solidFill>
-          <a:ln w="12700">
+          <a:ln w="25400">
             <a:solidFill>
-              <a:srgbClr val="E3E9E6"/>
+              <a:srgbClr val="0F9F6E"/>
             </a:solidFill>
             <a:prstDash val="solid"/>
           </a:ln>
@@ -4909,8 +5310,8 @@
         </p:nvSpPr>
         <p:spPr>
           <a:xfrm>
-            <a:off x="4663440" y="3200400"/>
-            <a:ext cx="2834640" cy="274320"/>
+            <a:off x="6428232" y="3246120"/>
+            <a:ext cx="4754880" cy="274320"/>
           </a:xfrm>
           <a:prstGeom prst="rect">
             <a:avLst/>
@@ -4934,7 +5335,7 @@
                 <a:ea typeface="Arial" pitchFamily="34" charset="-122"/>
                 <a:cs typeface="Arial" pitchFamily="34" charset="-120"/>
               </a:rPr>
-              <a:t>ROLE</a:t>
+              <a:t>PREMIUM</a:t>
             </a:r>
             <a:endParaRPr lang="en-US" sz="1100" dirty="0"/>
           </a:p>
@@ -4948,8 +5349,8 @@
         </p:nvSpPr>
         <p:spPr>
           <a:xfrm>
-            <a:off x="4663440" y="3520440"/>
-            <a:ext cx="2834640" cy="548640"/>
+            <a:off x="6428232" y="3566160"/>
+            <a:ext cx="4754880" cy="548640"/>
           </a:xfrm>
           <a:prstGeom prst="rect">
             <a:avLst/>
@@ -4967,13 +5368,13 @@
             <a:r>
               <a:rPr lang="en-US" sz="2400" b="1" dirty="0">
                 <a:solidFill>
-                  <a:srgbClr val="0F9F6E"/>
-                </a:solidFill>
-                <a:latin typeface="Arial" pitchFamily="34" charset="0"/>
-                <a:ea typeface="Arial" pitchFamily="34" charset="-122"/>
-                <a:cs typeface="Arial" pitchFamily="34" charset="-120"/>
-              </a:rPr>
-              <a:t>[Name]</a:t>
+                  <a:srgbClr val="0F1F1A"/>
+                </a:solidFill>
+                <a:latin typeface="Arial" pitchFamily="34" charset="0"/>
+                <a:ea typeface="Arial" pitchFamily="34" charset="-122"/>
+                <a:cs typeface="Arial" pitchFamily="34" charset="-120"/>
+              </a:rPr>
+              <a:t>25 JOD / month</a:t>
             </a:r>
             <a:endParaRPr lang="en-US" sz="2400" dirty="0"/>
           </a:p>
@@ -4987,8 +5388,8 @@
         </p:nvSpPr>
         <p:spPr>
           <a:xfrm>
-            <a:off x="4663440" y="4114800"/>
-            <a:ext cx="2834640" cy="1097280"/>
+            <a:off x="6428232" y="4160520"/>
+            <a:ext cx="4754880" cy="1645920"/>
           </a:xfrm>
           <a:prstGeom prst="rect">
             <a:avLst/>
@@ -5004,168 +5405,56 @@
               <a:buNone/>
             </a:pPr>
             <a:r>
-              <a:rPr lang="en-US" sz="1700" dirty="0">
-                <a:solidFill>
-                  <a:srgbClr val="333333"/>
-                </a:solidFill>
-                <a:latin typeface="Arial" pitchFamily="34" charset="0"/>
-                <a:ea typeface="Arial" pitchFamily="34" charset="-122"/>
-                <a:cs typeface="Arial" pitchFamily="34" charset="-120"/>
-              </a:rPr>
-              <a:t>[Role]</a:t>
-            </a:r>
-            <a:endParaRPr lang="en-US" sz="1700" dirty="0"/>
-          </a:p>
-        </p:txBody>
-      </p:sp>
-      <p:sp>
-        <p:nvSpPr>
-          <p:cNvPr id="15" name="Shape 13"/>
-          <p:cNvSpPr/>
-          <p:nvPr/>
-        </p:nvSpPr>
-        <p:spPr>
-          <a:xfrm>
-            <a:off x="8046720" y="3017520"/>
-            <a:ext cx="3383280" cy="2377440"/>
-          </a:xfrm>
-          <a:prstGeom prst="roundRect">
-            <a:avLst>
-              <a:gd name="adj" fmla="val 6923"/>
-            </a:avLst>
-          </a:prstGeom>
-          <a:solidFill>
-            <a:srgbClr val="FFFFFF"/>
-          </a:solidFill>
-          <a:ln w="12700">
-            <a:solidFill>
-              <a:srgbClr val="E3E9E6"/>
-            </a:solidFill>
-            <a:prstDash val="solid"/>
-          </a:ln>
-          <a:effectLst>
-            <a:outerShdw sx="100000" sy="100000" kx="0" ky="0" algn="bl" rotWithShape="0" blurRad="127000" dist="38100" dir="5400000">
-              <a:srgbClr val="103020">
-                <a:alpha val="12000"/>
-              </a:srgbClr>
-            </a:outerShdw>
-          </a:effectLst>
-        </p:spPr>
-      </p:sp>
-      <p:sp>
-        <p:nvSpPr>
-          <p:cNvPr id="16" name="Text 14"/>
-          <p:cNvSpPr/>
-          <p:nvPr/>
-        </p:nvSpPr>
-        <p:spPr>
-          <a:xfrm>
-            <a:off x="8321040" y="3200400"/>
-            <a:ext cx="2834640" cy="274320"/>
-          </a:xfrm>
-          <a:prstGeom prst="rect">
-            <a:avLst/>
-          </a:prstGeom>
-          <a:noFill/>
-          <a:ln/>
-        </p:spPr>
-        <p:txBody>
-          <a:bodyPr wrap="square" rtlCol="0" anchor="ctr"/>
-          <a:lstStyle/>
-          <a:p>
-            <a:pPr indent="0" marL="0">
-              <a:buNone/>
-            </a:pPr>
-            <a:r>
-              <a:rPr lang="en-US" sz="1100" b="1" dirty="0">
-                <a:solidFill>
-                  <a:srgbClr val="0F9F6E"/>
-                </a:solidFill>
-                <a:latin typeface="Arial" pitchFamily="34" charset="0"/>
-                <a:ea typeface="Arial" pitchFamily="34" charset="-122"/>
-                <a:cs typeface="Arial" pitchFamily="34" charset="-120"/>
-              </a:rPr>
-              <a:t>ROLE</a:t>
-            </a:r>
-            <a:endParaRPr lang="en-US" sz="1100" dirty="0"/>
-          </a:p>
-        </p:txBody>
-      </p:sp>
-      <p:sp>
-        <p:nvSpPr>
-          <p:cNvPr id="17" name="Text 15"/>
-          <p:cNvSpPr/>
-          <p:nvPr/>
-        </p:nvSpPr>
-        <p:spPr>
-          <a:xfrm>
-            <a:off x="8321040" y="3520440"/>
-            <a:ext cx="2834640" cy="548640"/>
-          </a:xfrm>
-          <a:prstGeom prst="rect">
-            <a:avLst/>
-          </a:prstGeom>
-          <a:noFill/>
-          <a:ln/>
-        </p:spPr>
-        <p:txBody>
-          <a:bodyPr wrap="square" rtlCol="0" anchor="ctr"/>
-          <a:lstStyle/>
-          <a:p>
-            <a:pPr indent="0" marL="0">
-              <a:buNone/>
-            </a:pPr>
-            <a:r>
-              <a:rPr lang="en-US" sz="2400" b="1" dirty="0">
-                <a:solidFill>
-                  <a:srgbClr val="0F9F6E"/>
-                </a:solidFill>
-                <a:latin typeface="Arial" pitchFamily="34" charset="0"/>
-                <a:ea typeface="Arial" pitchFamily="34" charset="-122"/>
-                <a:cs typeface="Arial" pitchFamily="34" charset="-120"/>
-              </a:rPr>
-              <a:t>[Name]</a:t>
-            </a:r>
-            <a:endParaRPr lang="en-US" sz="2400" dirty="0"/>
-          </a:p>
-        </p:txBody>
-      </p:sp>
-      <p:sp>
-        <p:nvSpPr>
-          <p:cNvPr id="18" name="Text 16"/>
-          <p:cNvSpPr/>
-          <p:nvPr/>
-        </p:nvSpPr>
-        <p:spPr>
-          <a:xfrm>
-            <a:off x="8321040" y="4114800"/>
-            <a:ext cx="2834640" cy="1097280"/>
-          </a:xfrm>
-          <a:prstGeom prst="rect">
-            <a:avLst/>
-          </a:prstGeom>
-          <a:noFill/>
-          <a:ln/>
-        </p:spPr>
-        <p:txBody>
-          <a:bodyPr wrap="square" rtlCol="0" anchor="t"/>
-          <a:lstStyle/>
-          <a:p>
-            <a:pPr indent="0" marL="0">
-              <a:buNone/>
-            </a:pPr>
-            <a:r>
-              <a:rPr lang="en-US" sz="1700" dirty="0">
-                <a:solidFill>
-                  <a:srgbClr val="333333"/>
-                </a:solidFill>
-                <a:latin typeface="Arial" pitchFamily="34" charset="0"/>
-                <a:ea typeface="Arial" pitchFamily="34" charset="-122"/>
-                <a:cs typeface="Arial" pitchFamily="34" charset="-120"/>
-              </a:rPr>
-              <a:t>[Role]</a:t>
-            </a:r>
-            <a:endParaRPr lang="en-US" sz="1700" dirty="0"/>
+              <a:rPr lang="en-US" sz="1800" dirty="0">
+                <a:solidFill>
+                  <a:srgbClr val="222222"/>
+                </a:solidFill>
+                <a:latin typeface="Arial" pitchFamily="34" charset="0"/>
+                <a:ea typeface="Arial" pitchFamily="34" charset="-122"/>
+                <a:cs typeface="Arial" pitchFamily="34" charset="-120"/>
+              </a:rPr>
+              <a:t>Unlimited invites. Priority access to new candidates.</a:t>
+            </a:r>
+            <a:endParaRPr lang="en-US" sz="1800" dirty="0"/>
+          </a:p>
+        </p:txBody>
+      </p:sp>
+      <p:sp>
+        <p:nvSpPr>
+          <p:cNvPr id="15" name="Text 13"/>
+          <p:cNvSpPr/>
+          <p:nvPr/>
+        </p:nvSpPr>
+        <p:spPr>
+          <a:xfrm>
+            <a:off x="731520" y="5989320"/>
+            <a:ext cx="7315200" cy="274320"/>
+          </a:xfrm>
+          <a:prstGeom prst="rect">
+            <a:avLst/>
+          </a:prstGeom>
+          <a:noFill/>
+          <a:ln/>
+        </p:spPr>
+        <p:txBody>
+          <a:bodyPr wrap="square" rtlCol="0" anchor="ctr"/>
+          <a:lstStyle/>
+          <a:p>
+            <a:pPr indent="0" marL="0">
+              <a:buNone/>
+            </a:pPr>
+            <a:r>
+              <a:rPr lang="en-US" sz="1000" dirty="0">
+                <a:solidFill>
+                  <a:srgbClr val="5F6F68"/>
+                </a:solidFill>
+                <a:latin typeface="Arial" pitchFamily="34" charset="0"/>
+                <a:ea typeface="Arial" pitchFamily="34" charset="-122"/>
+                <a:cs typeface="Arial" pitchFamily="34" charset="-120"/>
+              </a:rPr>
+              <a:t>Demo note: payments are simulated.</a:t>
+            </a:r>
+            <a:endParaRPr lang="en-US" sz="1000" dirty="0"/>
           </a:p>
         </p:txBody>
       </p:sp>
@@ -5238,7 +5527,7 @@
                 <a:ea typeface="Arial" pitchFamily="34" charset="-122"/>
                 <a:cs typeface="Arial" pitchFamily="34" charset="-120"/>
               </a:rPr>
-              <a:t>08 // THE ASK · 15 SEC</a:t>
+              <a:t>07 // TEAM · 10 SEC</a:t>
             </a:r>
             <a:endParaRPr lang="en-US" sz="1200" dirty="0"/>
           </a:p>
@@ -5316,7 +5605,675 @@
                 <a:ea typeface="Arial" pitchFamily="34" charset="-122"/>
                 <a:cs typeface="Arial" pitchFamily="34" charset="-120"/>
               </a:rPr>
-              <a:t>08 / 08</a:t>
+              <a:t>08 / 09</a:t>
+            </a:r>
+            <a:endParaRPr lang="en-US" sz="1000" dirty="0"/>
+          </a:p>
+        </p:txBody>
+      </p:sp>
+      <p:sp>
+        <p:nvSpPr>
+          <p:cNvPr id="5" name="Text 3"/>
+          <p:cNvSpPr/>
+          <p:nvPr/>
+        </p:nvSpPr>
+        <p:spPr>
+          <a:xfrm>
+            <a:off x="731520" y="1508760"/>
+            <a:ext cx="10698480" cy="1188720"/>
+          </a:xfrm>
+          <a:prstGeom prst="rect">
+            <a:avLst/>
+          </a:prstGeom>
+          <a:noFill/>
+          <a:ln/>
+        </p:spPr>
+        <p:txBody>
+          <a:bodyPr wrap="square" rtlCol="0" anchor="t"/>
+          <a:lstStyle/>
+          <a:p>
+            <a:pPr indent="0" marL="0">
+              <a:buNone/>
+            </a:pPr>
+            <a:r>
+              <a:rPr lang="en-US" sz="4400" b="1" dirty="0">
+                <a:solidFill>
+                  <a:srgbClr val="0F1F1A"/>
+                </a:solidFill>
+                <a:latin typeface="Arial" pitchFamily="34" charset="0"/>
+                <a:ea typeface="Arial" pitchFamily="34" charset="-122"/>
+                <a:cs typeface="Arial" pitchFamily="34" charset="-120"/>
+              </a:rPr>
+              <a:t>The team.</a:t>
+            </a:r>
+            <a:endParaRPr lang="en-US" sz="4400" dirty="0"/>
+          </a:p>
+        </p:txBody>
+      </p:sp>
+      <p:sp>
+        <p:nvSpPr>
+          <p:cNvPr id="6" name="Shape 4"/>
+          <p:cNvSpPr/>
+          <p:nvPr/>
+        </p:nvSpPr>
+        <p:spPr>
+          <a:xfrm>
+            <a:off x="731520" y="2743200"/>
+            <a:ext cx="10725912" cy="0"/>
+          </a:xfrm>
+          <a:prstGeom prst="line">
+            <a:avLst/>
+          </a:prstGeom>
+          <a:noFill/>
+          <a:ln w="19050">
+            <a:solidFill>
+              <a:srgbClr val="CBD5D0"/>
+            </a:solidFill>
+            <a:prstDash val="solid"/>
+          </a:ln>
+        </p:spPr>
+      </p:sp>
+      <p:sp>
+        <p:nvSpPr>
+          <p:cNvPr id="7" name="Shape 5"/>
+          <p:cNvSpPr/>
+          <p:nvPr/>
+        </p:nvSpPr>
+        <p:spPr>
+          <a:xfrm>
+            <a:off x="731520" y="3017520"/>
+            <a:ext cx="3383280" cy="2377440"/>
+          </a:xfrm>
+          <a:prstGeom prst="roundRect">
+            <a:avLst>
+              <a:gd name="adj" fmla="val 6923"/>
+            </a:avLst>
+          </a:prstGeom>
+          <a:solidFill>
+            <a:srgbClr val="FFFFFF"/>
+          </a:solidFill>
+          <a:ln w="12700">
+            <a:solidFill>
+              <a:srgbClr val="E3E9E6"/>
+            </a:solidFill>
+            <a:prstDash val="solid"/>
+          </a:ln>
+          <a:effectLst>
+            <a:outerShdw sx="100000" sy="100000" kx="0" ky="0" algn="bl" rotWithShape="0" blurRad="127000" dist="38100" dir="5400000">
+              <a:srgbClr val="103020">
+                <a:alpha val="12000"/>
+              </a:srgbClr>
+            </a:outerShdw>
+          </a:effectLst>
+        </p:spPr>
+      </p:sp>
+      <p:sp>
+        <p:nvSpPr>
+          <p:cNvPr id="8" name="Text 6"/>
+          <p:cNvSpPr/>
+          <p:nvPr/>
+        </p:nvSpPr>
+        <p:spPr>
+          <a:xfrm>
+            <a:off x="1005840" y="3200400"/>
+            <a:ext cx="2834640" cy="274320"/>
+          </a:xfrm>
+          <a:prstGeom prst="rect">
+            <a:avLst/>
+          </a:prstGeom>
+          <a:noFill/>
+          <a:ln/>
+        </p:spPr>
+        <p:txBody>
+          <a:bodyPr wrap="square" rtlCol="0" anchor="ctr"/>
+          <a:lstStyle/>
+          <a:p>
+            <a:pPr indent="0" marL="0">
+              <a:buNone/>
+            </a:pPr>
+            <a:r>
+              <a:rPr lang="en-US" sz="1100" b="1" dirty="0">
+                <a:solidFill>
+                  <a:srgbClr val="0F9F6E"/>
+                </a:solidFill>
+                <a:latin typeface="Arial" pitchFamily="34" charset="0"/>
+                <a:ea typeface="Arial" pitchFamily="34" charset="-122"/>
+                <a:cs typeface="Arial" pitchFamily="34" charset="-120"/>
+              </a:rPr>
+              <a:t>ROLE</a:t>
+            </a:r>
+            <a:endParaRPr lang="en-US" sz="1100" dirty="0"/>
+          </a:p>
+        </p:txBody>
+      </p:sp>
+      <p:sp>
+        <p:nvSpPr>
+          <p:cNvPr id="9" name="Text 7"/>
+          <p:cNvSpPr/>
+          <p:nvPr/>
+        </p:nvSpPr>
+        <p:spPr>
+          <a:xfrm>
+            <a:off x="1005840" y="3520440"/>
+            <a:ext cx="2834640" cy="548640"/>
+          </a:xfrm>
+          <a:prstGeom prst="rect">
+            <a:avLst/>
+          </a:prstGeom>
+          <a:noFill/>
+          <a:ln/>
+        </p:spPr>
+        <p:txBody>
+          <a:bodyPr wrap="square" rtlCol="0" anchor="ctr"/>
+          <a:lstStyle/>
+          <a:p>
+            <a:pPr indent="0" marL="0">
+              <a:buNone/>
+            </a:pPr>
+            <a:r>
+              <a:rPr lang="en-US" sz="2400" b="1" dirty="0">
+                <a:solidFill>
+                  <a:srgbClr val="0F9F6E"/>
+                </a:solidFill>
+                <a:latin typeface="Arial" pitchFamily="34" charset="0"/>
+                <a:ea typeface="Arial" pitchFamily="34" charset="-122"/>
+                <a:cs typeface="Arial" pitchFamily="34" charset="-120"/>
+              </a:rPr>
+              <a:t>[Name]</a:t>
+            </a:r>
+            <a:endParaRPr lang="en-US" sz="2400" dirty="0"/>
+          </a:p>
+        </p:txBody>
+      </p:sp>
+      <p:sp>
+        <p:nvSpPr>
+          <p:cNvPr id="10" name="Text 8"/>
+          <p:cNvSpPr/>
+          <p:nvPr/>
+        </p:nvSpPr>
+        <p:spPr>
+          <a:xfrm>
+            <a:off x="1005840" y="4114800"/>
+            <a:ext cx="2834640" cy="1097280"/>
+          </a:xfrm>
+          <a:prstGeom prst="rect">
+            <a:avLst/>
+          </a:prstGeom>
+          <a:noFill/>
+          <a:ln/>
+        </p:spPr>
+        <p:txBody>
+          <a:bodyPr wrap="square" rtlCol="0" anchor="t"/>
+          <a:lstStyle/>
+          <a:p>
+            <a:pPr indent="0" marL="0">
+              <a:buNone/>
+            </a:pPr>
+            <a:r>
+              <a:rPr lang="en-US" sz="1700" dirty="0">
+                <a:solidFill>
+                  <a:srgbClr val="333333"/>
+                </a:solidFill>
+                <a:latin typeface="Arial" pitchFamily="34" charset="0"/>
+                <a:ea typeface="Arial" pitchFamily="34" charset="-122"/>
+                <a:cs typeface="Arial" pitchFamily="34" charset="-120"/>
+              </a:rPr>
+              <a:t>[Role]</a:t>
+            </a:r>
+            <a:endParaRPr lang="en-US" sz="1700" dirty="0"/>
+          </a:p>
+        </p:txBody>
+      </p:sp>
+      <p:sp>
+        <p:nvSpPr>
+          <p:cNvPr id="11" name="Shape 9"/>
+          <p:cNvSpPr/>
+          <p:nvPr/>
+        </p:nvSpPr>
+        <p:spPr>
+          <a:xfrm>
+            <a:off x="4389120" y="3017520"/>
+            <a:ext cx="3383280" cy="2377440"/>
+          </a:xfrm>
+          <a:prstGeom prst="roundRect">
+            <a:avLst>
+              <a:gd name="adj" fmla="val 6923"/>
+            </a:avLst>
+          </a:prstGeom>
+          <a:solidFill>
+            <a:srgbClr val="FFFFFF"/>
+          </a:solidFill>
+          <a:ln w="12700">
+            <a:solidFill>
+              <a:srgbClr val="E3E9E6"/>
+            </a:solidFill>
+            <a:prstDash val="solid"/>
+          </a:ln>
+          <a:effectLst>
+            <a:outerShdw sx="100000" sy="100000" kx="0" ky="0" algn="bl" rotWithShape="0" blurRad="127000" dist="38100" dir="5400000">
+              <a:srgbClr val="103020">
+                <a:alpha val="12000"/>
+              </a:srgbClr>
+            </a:outerShdw>
+          </a:effectLst>
+        </p:spPr>
+      </p:sp>
+      <p:sp>
+        <p:nvSpPr>
+          <p:cNvPr id="12" name="Text 10"/>
+          <p:cNvSpPr/>
+          <p:nvPr/>
+        </p:nvSpPr>
+        <p:spPr>
+          <a:xfrm>
+            <a:off x="4663440" y="3200400"/>
+            <a:ext cx="2834640" cy="274320"/>
+          </a:xfrm>
+          <a:prstGeom prst="rect">
+            <a:avLst/>
+          </a:prstGeom>
+          <a:noFill/>
+          <a:ln/>
+        </p:spPr>
+        <p:txBody>
+          <a:bodyPr wrap="square" rtlCol="0" anchor="ctr"/>
+          <a:lstStyle/>
+          <a:p>
+            <a:pPr indent="0" marL="0">
+              <a:buNone/>
+            </a:pPr>
+            <a:r>
+              <a:rPr lang="en-US" sz="1100" b="1" dirty="0">
+                <a:solidFill>
+                  <a:srgbClr val="0F9F6E"/>
+                </a:solidFill>
+                <a:latin typeface="Arial" pitchFamily="34" charset="0"/>
+                <a:ea typeface="Arial" pitchFamily="34" charset="-122"/>
+                <a:cs typeface="Arial" pitchFamily="34" charset="-120"/>
+              </a:rPr>
+              <a:t>ROLE</a:t>
+            </a:r>
+            <a:endParaRPr lang="en-US" sz="1100" dirty="0"/>
+          </a:p>
+        </p:txBody>
+      </p:sp>
+      <p:sp>
+        <p:nvSpPr>
+          <p:cNvPr id="13" name="Text 11"/>
+          <p:cNvSpPr/>
+          <p:nvPr/>
+        </p:nvSpPr>
+        <p:spPr>
+          <a:xfrm>
+            <a:off x="4663440" y="3520440"/>
+            <a:ext cx="2834640" cy="548640"/>
+          </a:xfrm>
+          <a:prstGeom prst="rect">
+            <a:avLst/>
+          </a:prstGeom>
+          <a:noFill/>
+          <a:ln/>
+        </p:spPr>
+        <p:txBody>
+          <a:bodyPr wrap="square" rtlCol="0" anchor="ctr"/>
+          <a:lstStyle/>
+          <a:p>
+            <a:pPr indent="0" marL="0">
+              <a:buNone/>
+            </a:pPr>
+            <a:r>
+              <a:rPr lang="en-US" sz="2400" b="1" dirty="0">
+                <a:solidFill>
+                  <a:srgbClr val="0F9F6E"/>
+                </a:solidFill>
+                <a:latin typeface="Arial" pitchFamily="34" charset="0"/>
+                <a:ea typeface="Arial" pitchFamily="34" charset="-122"/>
+                <a:cs typeface="Arial" pitchFamily="34" charset="-120"/>
+              </a:rPr>
+              <a:t>[Name]</a:t>
+            </a:r>
+            <a:endParaRPr lang="en-US" sz="2400" dirty="0"/>
+          </a:p>
+        </p:txBody>
+      </p:sp>
+      <p:sp>
+        <p:nvSpPr>
+          <p:cNvPr id="14" name="Text 12"/>
+          <p:cNvSpPr/>
+          <p:nvPr/>
+        </p:nvSpPr>
+        <p:spPr>
+          <a:xfrm>
+            <a:off x="4663440" y="4114800"/>
+            <a:ext cx="2834640" cy="1097280"/>
+          </a:xfrm>
+          <a:prstGeom prst="rect">
+            <a:avLst/>
+          </a:prstGeom>
+          <a:noFill/>
+          <a:ln/>
+        </p:spPr>
+        <p:txBody>
+          <a:bodyPr wrap="square" rtlCol="0" anchor="t"/>
+          <a:lstStyle/>
+          <a:p>
+            <a:pPr indent="0" marL="0">
+              <a:buNone/>
+            </a:pPr>
+            <a:r>
+              <a:rPr lang="en-US" sz="1700" dirty="0">
+                <a:solidFill>
+                  <a:srgbClr val="333333"/>
+                </a:solidFill>
+                <a:latin typeface="Arial" pitchFamily="34" charset="0"/>
+                <a:ea typeface="Arial" pitchFamily="34" charset="-122"/>
+                <a:cs typeface="Arial" pitchFamily="34" charset="-120"/>
+              </a:rPr>
+              <a:t>[Role]</a:t>
+            </a:r>
+            <a:endParaRPr lang="en-US" sz="1700" dirty="0"/>
+          </a:p>
+        </p:txBody>
+      </p:sp>
+      <p:sp>
+        <p:nvSpPr>
+          <p:cNvPr id="15" name="Shape 13"/>
+          <p:cNvSpPr/>
+          <p:nvPr/>
+        </p:nvSpPr>
+        <p:spPr>
+          <a:xfrm>
+            <a:off x="8046720" y="3017520"/>
+            <a:ext cx="3383280" cy="2377440"/>
+          </a:xfrm>
+          <a:prstGeom prst="roundRect">
+            <a:avLst>
+              <a:gd name="adj" fmla="val 6923"/>
+            </a:avLst>
+          </a:prstGeom>
+          <a:solidFill>
+            <a:srgbClr val="FFFFFF"/>
+          </a:solidFill>
+          <a:ln w="12700">
+            <a:solidFill>
+              <a:srgbClr val="E3E9E6"/>
+            </a:solidFill>
+            <a:prstDash val="solid"/>
+          </a:ln>
+          <a:effectLst>
+            <a:outerShdw sx="100000" sy="100000" kx="0" ky="0" algn="bl" rotWithShape="0" blurRad="127000" dist="38100" dir="5400000">
+              <a:srgbClr val="103020">
+                <a:alpha val="12000"/>
+              </a:srgbClr>
+            </a:outerShdw>
+          </a:effectLst>
+        </p:spPr>
+      </p:sp>
+      <p:sp>
+        <p:nvSpPr>
+          <p:cNvPr id="16" name="Text 14"/>
+          <p:cNvSpPr/>
+          <p:nvPr/>
+        </p:nvSpPr>
+        <p:spPr>
+          <a:xfrm>
+            <a:off x="8321040" y="3200400"/>
+            <a:ext cx="2834640" cy="274320"/>
+          </a:xfrm>
+          <a:prstGeom prst="rect">
+            <a:avLst/>
+          </a:prstGeom>
+          <a:noFill/>
+          <a:ln/>
+        </p:spPr>
+        <p:txBody>
+          <a:bodyPr wrap="square" rtlCol="0" anchor="ctr"/>
+          <a:lstStyle/>
+          <a:p>
+            <a:pPr indent="0" marL="0">
+              <a:buNone/>
+            </a:pPr>
+            <a:r>
+              <a:rPr lang="en-US" sz="1100" b="1" dirty="0">
+                <a:solidFill>
+                  <a:srgbClr val="0F9F6E"/>
+                </a:solidFill>
+                <a:latin typeface="Arial" pitchFamily="34" charset="0"/>
+                <a:ea typeface="Arial" pitchFamily="34" charset="-122"/>
+                <a:cs typeface="Arial" pitchFamily="34" charset="-120"/>
+              </a:rPr>
+              <a:t>ROLE</a:t>
+            </a:r>
+            <a:endParaRPr lang="en-US" sz="1100" dirty="0"/>
+          </a:p>
+        </p:txBody>
+      </p:sp>
+      <p:sp>
+        <p:nvSpPr>
+          <p:cNvPr id="17" name="Text 15"/>
+          <p:cNvSpPr/>
+          <p:nvPr/>
+        </p:nvSpPr>
+        <p:spPr>
+          <a:xfrm>
+            <a:off x="8321040" y="3520440"/>
+            <a:ext cx="2834640" cy="548640"/>
+          </a:xfrm>
+          <a:prstGeom prst="rect">
+            <a:avLst/>
+          </a:prstGeom>
+          <a:noFill/>
+          <a:ln/>
+        </p:spPr>
+        <p:txBody>
+          <a:bodyPr wrap="square" rtlCol="0" anchor="ctr"/>
+          <a:lstStyle/>
+          <a:p>
+            <a:pPr indent="0" marL="0">
+              <a:buNone/>
+            </a:pPr>
+            <a:r>
+              <a:rPr lang="en-US" sz="2400" b="1" dirty="0">
+                <a:solidFill>
+                  <a:srgbClr val="0F9F6E"/>
+                </a:solidFill>
+                <a:latin typeface="Arial" pitchFamily="34" charset="0"/>
+                <a:ea typeface="Arial" pitchFamily="34" charset="-122"/>
+                <a:cs typeface="Arial" pitchFamily="34" charset="-120"/>
+              </a:rPr>
+              <a:t>[Name]</a:t>
+            </a:r>
+            <a:endParaRPr lang="en-US" sz="2400" dirty="0"/>
+          </a:p>
+        </p:txBody>
+      </p:sp>
+      <p:sp>
+        <p:nvSpPr>
+          <p:cNvPr id="18" name="Text 16"/>
+          <p:cNvSpPr/>
+          <p:nvPr/>
+        </p:nvSpPr>
+        <p:spPr>
+          <a:xfrm>
+            <a:off x="8321040" y="4114800"/>
+            <a:ext cx="2834640" cy="1097280"/>
+          </a:xfrm>
+          <a:prstGeom prst="rect">
+            <a:avLst/>
+          </a:prstGeom>
+          <a:noFill/>
+          <a:ln/>
+        </p:spPr>
+        <p:txBody>
+          <a:bodyPr wrap="square" rtlCol="0" anchor="t"/>
+          <a:lstStyle/>
+          <a:p>
+            <a:pPr indent="0" marL="0">
+              <a:buNone/>
+            </a:pPr>
+            <a:r>
+              <a:rPr lang="en-US" sz="1700" dirty="0">
+                <a:solidFill>
+                  <a:srgbClr val="333333"/>
+                </a:solidFill>
+                <a:latin typeface="Arial" pitchFamily="34" charset="0"/>
+                <a:ea typeface="Arial" pitchFamily="34" charset="-122"/>
+                <a:cs typeface="Arial" pitchFamily="34" charset="-120"/>
+              </a:rPr>
+              <a:t>[Role]</a:t>
+            </a:r>
+            <a:endParaRPr lang="en-US" sz="1700" dirty="0"/>
+          </a:p>
+        </p:txBody>
+      </p:sp>
+    </p:spTree>
+  </p:cSld>
+  <p:clrMapOvr>
+    <a:masterClrMapping/>
+  </p:clrMapOvr>
+</p:sld>
+</file>
+
+<file path=ppt/slides/slide9.xml><?xml version="1.0" encoding="utf-8"?>
+<p:sld xmlns:a="http://schemas.openxmlformats.org/drawingml/2006/main" xmlns:r="http://schemas.openxmlformats.org/officeDocument/2006/relationships" xmlns:p="http://schemas.openxmlformats.org/presentationml/2006/main">
+  <p:cSld name="Slide 9">
+    <p:bg>
+      <p:bgPr>
+        <a:solidFill>
+          <a:srgbClr val="F4F7F6"/>
+        </a:solidFill>
+      </p:bgPr>
+    </p:bg>
+    <p:spTree>
+      <p:nvGrpSpPr>
+        <p:cNvPr id="1" name=""/>
+        <p:cNvGrpSpPr/>
+        <p:nvPr/>
+      </p:nvGrpSpPr>
+      <p:grpSpPr>
+        <a:xfrm>
+          <a:off x="0" y="0"/>
+          <a:ext cx="0" cy="0"/>
+          <a:chOff x="0" y="0"/>
+          <a:chExt cx="0" cy="0"/>
+        </a:xfrm>
+      </p:grpSpPr>
+      <p:sp>
+        <p:nvSpPr>
+          <p:cNvPr id="2" name="Text 0"/>
+          <p:cNvSpPr/>
+          <p:nvPr/>
+        </p:nvSpPr>
+        <p:spPr>
+          <a:xfrm>
+            <a:off x="731520" y="640080"/>
+            <a:ext cx="5029200" cy="365760"/>
+          </a:xfrm>
+          <a:prstGeom prst="roundRect">
+            <a:avLst>
+              <a:gd name="adj" fmla="val 50000"/>
+            </a:avLst>
+          </a:prstGeom>
+          <a:solidFill>
+            <a:srgbClr val="E8F7F0"/>
+          </a:solidFill>
+          <a:ln/>
+        </p:spPr>
+        <p:txBody>
+          <a:bodyPr wrap="square" rtlCol="0" anchor="ctr"/>
+          <a:lstStyle/>
+          <a:p>
+            <a:pPr algn="ctr" indent="0" marL="0">
+              <a:buNone/>
+            </a:pPr>
+            <a:r>
+              <a:rPr lang="en-US" sz="1200" b="1" spc="200" kern="0" dirty="0">
+                <a:solidFill>
+                  <a:srgbClr val="0B8A5E"/>
+                </a:solidFill>
+                <a:latin typeface="Arial" pitchFamily="34" charset="0"/>
+                <a:ea typeface="Arial" pitchFamily="34" charset="-122"/>
+                <a:cs typeface="Arial" pitchFamily="34" charset="-120"/>
+              </a:rPr>
+              <a:t>08 // THE ASK · 15 SEC</a:t>
+            </a:r>
+            <a:endParaRPr lang="en-US" sz="1200" dirty="0"/>
+          </a:p>
+        </p:txBody>
+      </p:sp>
+      <p:sp>
+        <p:nvSpPr>
+          <p:cNvPr id="3" name="Text 1"/>
+          <p:cNvSpPr/>
+          <p:nvPr/>
+        </p:nvSpPr>
+        <p:spPr>
+          <a:xfrm>
+            <a:off x="731520" y="6400800"/>
+            <a:ext cx="3657600" cy="274320"/>
+          </a:xfrm>
+          <a:prstGeom prst="rect">
+            <a:avLst/>
+          </a:prstGeom>
+          <a:noFill/>
+          <a:ln/>
+        </p:spPr>
+        <p:txBody>
+          <a:bodyPr wrap="square" rtlCol="0" anchor="ctr"/>
+          <a:lstStyle/>
+          <a:p>
+            <a:pPr indent="0" marL="0">
+              <a:buNone/>
+            </a:pPr>
+            <a:r>
+              <a:rPr lang="en-US" sz="1000" dirty="0">
+                <a:solidFill>
+                  <a:srgbClr val="5F6F68"/>
+                </a:solidFill>
+                <a:latin typeface="Arial" pitchFamily="34" charset="0"/>
+                <a:ea typeface="Arial" pitchFamily="34" charset="-122"/>
+                <a:cs typeface="Arial" pitchFamily="34" charset="-120"/>
+              </a:rPr>
+              <a:t>MISH SENIOR</a:t>
+            </a:r>
+            <a:endParaRPr lang="en-US" sz="1000" dirty="0"/>
+          </a:p>
+        </p:txBody>
+      </p:sp>
+      <p:sp>
+        <p:nvSpPr>
+          <p:cNvPr id="4" name="Text 2"/>
+          <p:cNvSpPr/>
+          <p:nvPr/>
+        </p:nvSpPr>
+        <p:spPr>
+          <a:xfrm>
+            <a:off x="8686800" y="6400800"/>
+            <a:ext cx="2743200" cy="274320"/>
+          </a:xfrm>
+          <a:prstGeom prst="rect">
+            <a:avLst/>
+          </a:prstGeom>
+          <a:noFill/>
+          <a:ln/>
+        </p:spPr>
+        <p:txBody>
+          <a:bodyPr wrap="square" rtlCol="0" anchor="ctr"/>
+          <a:lstStyle/>
+          <a:p>
+            <a:pPr algn="r" indent="0" marL="0">
+              <a:buNone/>
+            </a:pPr>
+            <a:r>
+              <a:rPr lang="en-US" sz="1000" dirty="0">
+                <a:solidFill>
+                  <a:srgbClr val="5F6F68"/>
+                </a:solidFill>
+                <a:latin typeface="Arial" pitchFamily="34" charset="0"/>
+                <a:ea typeface="Arial" pitchFamily="34" charset="-122"/>
+                <a:cs typeface="Arial" pitchFamily="34" charset="-120"/>
+              </a:rPr>
+              <a:t>09 / 09</a:t>
             </a:r>
             <a:endParaRPr lang="en-US" sz="1000" dirty="0"/>
           </a:p>

</xml_diff>

<commit_message>
Update pitch presentation assets and metadata
Replit-Commit-Author: Agent
</commit_message>
<xml_diff>
--- a/presentation/Mish-Senior-Pitch.pptx
+++ b/presentation/Mish-Senior-Pitch.pptx
@@ -4235,7 +4235,7 @@
         <p:spPr>
           <a:xfrm>
             <a:off x="731520" y="2286000"/>
-            <a:ext cx="3108960" cy="0"/>
+            <a:ext cx="3291840" cy="0"/>
           </a:xfrm>
           <a:prstGeom prst="line">
             <a:avLst/>
@@ -4258,7 +4258,7 @@
         <p:spPr>
           <a:xfrm>
             <a:off x="731520" y="2377440"/>
-            <a:ext cx="3108960" cy="274320"/>
+            <a:ext cx="3291840" cy="274320"/>
           </a:xfrm>
           <a:prstGeom prst="rect">
             <a:avLst/>
@@ -4297,23 +4297,23 @@
         <p:spPr>
           <a:xfrm>
             <a:off x="731520" y="2697480"/>
-            <a:ext cx="3108960" cy="548640"/>
-          </a:xfrm>
-          <a:prstGeom prst="rect">
-            <a:avLst/>
-          </a:prstGeom>
-          <a:noFill/>
-          <a:ln/>
-        </p:spPr>
-        <p:txBody>
-          <a:bodyPr wrap="square" rtlCol="0" anchor="ctr"/>
-          <a:lstStyle/>
-          <a:p>
-            <a:pPr indent="0" marL="0">
-              <a:buNone/>
-            </a:pPr>
-            <a:r>
-              <a:rPr lang="en-US" sz="2000" b="1" dirty="0">
+            <a:ext cx="3383280" cy="548640"/>
+          </a:xfrm>
+          <a:prstGeom prst="rect">
+            <a:avLst/>
+          </a:prstGeom>
+          <a:noFill/>
+          <a:ln/>
+        </p:spPr>
+        <p:txBody>
+          <a:bodyPr wrap="square" rtlCol="0" anchor="ctr"/>
+          <a:lstStyle/>
+          <a:p>
+            <a:pPr indent="0" marL="0">
+              <a:buNone/>
+            </a:pPr>
+            <a:r>
+              <a:rPr lang="en-US" sz="1800" b="1" dirty="0">
                 <a:solidFill>
                   <a:srgbClr val="0F1F1A"/>
                 </a:solidFill>
@@ -4323,7 +4323,7 @@
               </a:rPr>
               <a:t>Fresh IT graduates</a:t>
             </a:r>
-            <a:endParaRPr lang="en-US" sz="2000" dirty="0"/>
+            <a:endParaRPr lang="en-US" sz="1800" dirty="0"/>
           </a:p>
         </p:txBody>
       </p:sp>
@@ -4336,7 +4336,7 @@
         <p:spPr>
           <a:xfrm>
             <a:off x="731520" y="3520440"/>
-            <a:ext cx="3108960" cy="0"/>
+            <a:ext cx="3291840" cy="0"/>
           </a:xfrm>
           <a:prstGeom prst="line">
             <a:avLst/>
@@ -4359,7 +4359,7 @@
         <p:spPr>
           <a:xfrm>
             <a:off x="731520" y="3611880"/>
-            <a:ext cx="3108960" cy="274320"/>
+            <a:ext cx="3291840" cy="274320"/>
           </a:xfrm>
           <a:prstGeom prst="rect">
             <a:avLst/>
@@ -4398,23 +4398,23 @@
         <p:spPr>
           <a:xfrm>
             <a:off x="731520" y="3931920"/>
-            <a:ext cx="3108960" cy="548640"/>
-          </a:xfrm>
-          <a:prstGeom prst="rect">
-            <a:avLst/>
-          </a:prstGeom>
-          <a:noFill/>
-          <a:ln/>
-        </p:spPr>
-        <p:txBody>
-          <a:bodyPr wrap="square" rtlCol="0" anchor="ctr"/>
-          <a:lstStyle/>
-          <a:p>
-            <a:pPr indent="0" marL="0">
-              <a:buNone/>
-            </a:pPr>
-            <a:r>
-              <a:rPr lang="en-US" sz="2000" b="1" dirty="0">
+            <a:ext cx="3383280" cy="548640"/>
+          </a:xfrm>
+          <a:prstGeom prst="rect">
+            <a:avLst/>
+          </a:prstGeom>
+          <a:noFill/>
+          <a:ln/>
+        </p:spPr>
+        <p:txBody>
+          <a:bodyPr wrap="square" rtlCol="0" anchor="ctr"/>
+          <a:lstStyle/>
+          <a:p>
+            <a:pPr indent="0" marL="0">
+              <a:buNone/>
+            </a:pPr>
+            <a:r>
+              <a:rPr lang="en-US" sz="2400" b="1" dirty="0">
                 <a:solidFill>
                   <a:srgbClr val="0F9F6E"/>
                 </a:solidFill>
@@ -4422,9 +4422,23 @@
                 <a:ea typeface="Arial" pitchFamily="34" charset="-122"/>
                 <a:cs typeface="Arial" pitchFamily="34" charset="-120"/>
               </a:rPr>
-              <a:t>[# of them in Jordan]</a:t>
-            </a:r>
-            <a:endParaRPr lang="en-US" sz="2000" dirty="0"/>
+              <a:t>4,500+ </a:t>
+            </a:r>
+            <a:pPr indent="0" marL="0">
+              <a:buNone/>
+            </a:pPr>
+            <a:r>
+              <a:rPr lang="en-US" sz="1800" b="1" dirty="0">
+                <a:solidFill>
+                  <a:srgbClr val="0F1F1A"/>
+                </a:solidFill>
+                <a:latin typeface="Arial" pitchFamily="34" charset="0"/>
+                <a:ea typeface="Arial" pitchFamily="34" charset="-122"/>
+                <a:cs typeface="Arial" pitchFamily="34" charset="-120"/>
+              </a:rPr>
+              <a:t>Annual ICT Graduates</a:t>
+            </a:r>
+            <a:endParaRPr lang="en-US" sz="2400" dirty="0"/>
           </a:p>
         </p:txBody>
       </p:sp>
@@ -4437,7 +4451,7 @@
         <p:spPr>
           <a:xfrm>
             <a:off x="731520" y="4754880"/>
-            <a:ext cx="3108960" cy="0"/>
+            <a:ext cx="3291840" cy="0"/>
           </a:xfrm>
           <a:prstGeom prst="line">
             <a:avLst/>
@@ -4460,7 +4474,7 @@
         <p:spPr>
           <a:xfrm>
             <a:off x="731520" y="4846320"/>
-            <a:ext cx="3108960" cy="274320"/>
+            <a:ext cx="3291840" cy="274320"/>
           </a:xfrm>
           <a:prstGeom prst="rect">
             <a:avLst/>
@@ -4499,23 +4513,23 @@
         <p:spPr>
           <a:xfrm>
             <a:off x="731520" y="5166360"/>
-            <a:ext cx="3108960" cy="548640"/>
-          </a:xfrm>
-          <a:prstGeom prst="rect">
-            <a:avLst/>
-          </a:prstGeom>
-          <a:noFill/>
-          <a:ln/>
-        </p:spPr>
-        <p:txBody>
-          <a:bodyPr wrap="square" rtlCol="0" anchor="ctr"/>
-          <a:lstStyle/>
-          <a:p>
-            <a:pPr indent="0" marL="0">
-              <a:buNone/>
-            </a:pPr>
-            <a:r>
-              <a:rPr lang="en-US" sz="2000" b="1" dirty="0">
+            <a:ext cx="3383280" cy="548640"/>
+          </a:xfrm>
+          <a:prstGeom prst="rect">
+            <a:avLst/>
+          </a:prstGeom>
+          <a:noFill/>
+          <a:ln/>
+        </p:spPr>
+        <p:txBody>
+          <a:bodyPr wrap="square" rtlCol="0" anchor="ctr"/>
+          <a:lstStyle/>
+          <a:p>
+            <a:pPr indent="0" marL="0">
+              <a:buNone/>
+            </a:pPr>
+            <a:r>
+              <a:rPr lang="en-US" sz="2400" b="1" dirty="0">
                 <a:solidFill>
                   <a:srgbClr val="0F9F6E"/>
                 </a:solidFill>
@@ -4523,9 +4537,23 @@
                 <a:ea typeface="Arial" pitchFamily="34" charset="-122"/>
                 <a:cs typeface="Arial" pitchFamily="34" charset="-120"/>
               </a:rPr>
-              <a:t>[# of them in MENA]</a:t>
-            </a:r>
-            <a:endParaRPr lang="en-US" sz="2000" dirty="0"/>
+              <a:t>100,000+ </a:t>
+            </a:r>
+            <a:pPr indent="0" marL="0">
+              <a:buNone/>
+            </a:pPr>
+            <a:r>
+              <a:rPr lang="en-US" sz="1800" b="1" dirty="0">
+                <a:solidFill>
+                  <a:srgbClr val="0F1F1A"/>
+                </a:solidFill>
+                <a:latin typeface="Arial" pitchFamily="34" charset="0"/>
+                <a:ea typeface="Arial" pitchFamily="34" charset="-122"/>
+                <a:cs typeface="Arial" pitchFamily="34" charset="-120"/>
+              </a:rPr>
+              <a:t>Annual IT Graduates</a:t>
+            </a:r>
+            <a:endParaRPr lang="en-US" sz="2400" dirty="0"/>
           </a:p>
         </p:txBody>
       </p:sp>
@@ -4685,7 +4713,7 @@
                 <a:ea typeface="Arial" pitchFamily="34" charset="-122"/>
                 <a:cs typeface="Arial" pitchFamily="34" charset="-120"/>
               </a:rPr>
-              <a:t>[COMPETITOR B]</a:t>
+              <a:t>KARAT</a:t>
             </a:r>
             <a:endParaRPr lang="en-US" sz="1200" dirty="0"/>
           </a:p>
@@ -4814,7 +4842,7 @@
                 <a:ea typeface="Arial" pitchFamily="34" charset="-122"/>
                 <a:cs typeface="Arial" pitchFamily="34" charset="-120"/>
               </a:rPr>
-              <a:t>[COMPETITOR C]</a:t>
+              <a:t>HACKERRANK</a:t>
             </a:r>
             <a:endParaRPr lang="en-US" sz="1200" dirty="0"/>
           </a:p>
@@ -4856,49 +4884,6 @@
               <a:t>← SENIORS ONLY          FOR FRESH GRADUATES →</a:t>
             </a:r>
             <a:endParaRPr lang="en-US" sz="1000" dirty="0"/>
-          </a:p>
-        </p:txBody>
-      </p:sp>
-      <p:sp>
-        <p:nvSpPr>
-          <p:cNvPr id="24" name="Text 22"/>
-          <p:cNvSpPr/>
-          <p:nvPr/>
-        </p:nvSpPr>
-        <p:spPr>
-          <a:xfrm>
-            <a:off x="10332720" y="640080"/>
-            <a:ext cx="1097280" cy="365760"/>
-          </a:xfrm>
-          <a:prstGeom prst="roundRect">
-            <a:avLst>
-              <a:gd name="adj" fmla="val 25000"/>
-            </a:avLst>
-          </a:prstGeom>
-          <a:solidFill>
-            <a:srgbClr val="0F1F1A"/>
-          </a:solidFill>
-          <a:ln/>
-        </p:spPr>
-        <p:txBody>
-          <a:bodyPr wrap="square" rtlCol="0" anchor="ctr"/>
-          <a:lstStyle/>
-          <a:p>
-            <a:pPr algn="ctr" indent="0" marL="0">
-              <a:buNone/>
-            </a:pPr>
-            <a:r>
-              <a:rPr lang="en-US" sz="1100" b="1" dirty="0">
-                <a:solidFill>
-                  <a:srgbClr val="FFFFFF"/>
-                </a:solidFill>
-                <a:latin typeface="Arial" pitchFamily="34" charset="0"/>
-                <a:ea typeface="Arial" pitchFamily="34" charset="-122"/>
-                <a:cs typeface="Arial" pitchFamily="34" charset="-120"/>
-              </a:rPr>
-              <a:t>15 SEC</a:t>
-            </a:r>
-            <a:endParaRPr lang="en-US" sz="1100" dirty="0"/>
           </a:p>
         </p:txBody>
       </p:sp>

</xml_diff>

<commit_message>
Update agent metadata and include pitch presentation assets
Replit-Commit-Author: Agent
</commit_message>
<xml_diff>
--- a/presentation/Mish-Senior-Pitch.pptx
+++ b/presentation/Mish-Senior-Pitch.pptx
@@ -5667,11 +5667,11 @@
         <p:spPr>
           <a:xfrm>
             <a:off x="731520" y="3017520"/>
-            <a:ext cx="3383280" cy="2377440"/>
+            <a:ext cx="5303520" cy="2926080"/>
           </a:xfrm>
           <a:prstGeom prst="roundRect">
             <a:avLst>
-              <a:gd name="adj" fmla="val 6923"/>
+              <a:gd name="adj" fmla="val 6250"/>
             </a:avLst>
           </a:prstGeom>
           <a:solidFill>
@@ -5700,8 +5700,8 @@
         </p:nvSpPr>
         <p:spPr>
           <a:xfrm>
-            <a:off x="1005840" y="3200400"/>
-            <a:ext cx="2834640" cy="274320"/>
+            <a:off x="1005840" y="3246120"/>
+            <a:ext cx="4754880" cy="274320"/>
           </a:xfrm>
           <a:prstGeom prst="rect">
             <a:avLst/>
@@ -5725,7 +5725,7 @@
                 <a:ea typeface="Arial" pitchFamily="34" charset="-122"/>
                 <a:cs typeface="Arial" pitchFamily="34" charset="-120"/>
               </a:rPr>
-              <a:t>ROLE</a:t>
+              <a:t>MOBILE APP DEVELOPER</a:t>
             </a:r>
             <a:endParaRPr lang="en-US" sz="1100" dirty="0"/>
           </a:p>
@@ -5739,8 +5739,8 @@
         </p:nvSpPr>
         <p:spPr>
           <a:xfrm>
-            <a:off x="1005840" y="3520440"/>
-            <a:ext cx="2834640" cy="548640"/>
+            <a:off x="1005840" y="3566160"/>
+            <a:ext cx="4754880" cy="548640"/>
           </a:xfrm>
           <a:prstGeom prst="rect">
             <a:avLst/>
@@ -5758,13 +5758,13 @@
             <a:r>
               <a:rPr lang="en-US" sz="2400" b="1" dirty="0">
                 <a:solidFill>
-                  <a:srgbClr val="0F9F6E"/>
-                </a:solidFill>
-                <a:latin typeface="Arial" pitchFamily="34" charset="0"/>
-                <a:ea typeface="Arial" pitchFamily="34" charset="-122"/>
-                <a:cs typeface="Arial" pitchFamily="34" charset="-120"/>
-              </a:rPr>
-              <a:t>[Name]</a:t>
+                  <a:srgbClr val="0F1F1A"/>
+                </a:solidFill>
+                <a:latin typeface="Arial" pitchFamily="34" charset="0"/>
+                <a:ea typeface="Arial" pitchFamily="34" charset="-122"/>
+                <a:cs typeface="Arial" pitchFamily="34" charset="-120"/>
+              </a:rPr>
+              <a:t>Dana Alamm</a:t>
             </a:r>
             <a:endParaRPr lang="en-US" sz="2400" dirty="0"/>
           </a:p>
@@ -5778,8 +5778,8 @@
         </p:nvSpPr>
         <p:spPr>
           <a:xfrm>
-            <a:off x="1005840" y="4114800"/>
-            <a:ext cx="2834640" cy="1097280"/>
+            <a:off x="1005840" y="4160520"/>
+            <a:ext cx="4754880" cy="1645920"/>
           </a:xfrm>
           <a:prstGeom prst="rect">
             <a:avLst/>
@@ -5795,17 +5795,17 @@
               <a:buNone/>
             </a:pPr>
             <a:r>
-              <a:rPr lang="en-US" sz="1700" dirty="0">
-                <a:solidFill>
-                  <a:srgbClr val="333333"/>
-                </a:solidFill>
-                <a:latin typeface="Arial" pitchFamily="34" charset="0"/>
-                <a:ea typeface="Arial" pitchFamily="34" charset="-122"/>
-                <a:cs typeface="Arial" pitchFamily="34" charset="-120"/>
-              </a:rPr>
-              <a:t>[Role]</a:t>
-            </a:r>
-            <a:endParaRPr lang="en-US" sz="1700" dirty="0"/>
+              <a:rPr lang="en-US" sz="1800" dirty="0">
+                <a:solidFill>
+                  <a:srgbClr val="222222"/>
+                </a:solidFill>
+                <a:latin typeface="Arial" pitchFamily="34" charset="0"/>
+                <a:ea typeface="Arial" pitchFamily="34" charset="-122"/>
+                <a:cs typeface="Arial" pitchFamily="34" charset="-120"/>
+              </a:rPr>
+              <a:t>Mobile app developer</a:t>
+            </a:r>
+            <a:endParaRPr lang="en-US" sz="1800" dirty="0"/>
           </a:p>
         </p:txBody>
       </p:sp>
@@ -5817,20 +5817,20 @@
         </p:nvSpPr>
         <p:spPr>
           <a:xfrm>
-            <a:off x="4389120" y="3017520"/>
-            <a:ext cx="3383280" cy="2377440"/>
+            <a:off x="6153912" y="3017520"/>
+            <a:ext cx="5303520" cy="2926080"/>
           </a:xfrm>
           <a:prstGeom prst="roundRect">
             <a:avLst>
-              <a:gd name="adj" fmla="val 6923"/>
+              <a:gd name="adj" fmla="val 6250"/>
             </a:avLst>
           </a:prstGeom>
           <a:solidFill>
             <a:srgbClr val="FFFFFF"/>
           </a:solidFill>
-          <a:ln w="12700">
+          <a:ln w="25400">
             <a:solidFill>
-              <a:srgbClr val="E3E9E6"/>
+              <a:srgbClr val="0F9F6E"/>
             </a:solidFill>
             <a:prstDash val="solid"/>
           </a:ln>
@@ -5851,8 +5851,8 @@
         </p:nvSpPr>
         <p:spPr>
           <a:xfrm>
-            <a:off x="4663440" y="3200400"/>
-            <a:ext cx="2834640" cy="274320"/>
+            <a:off x="6428232" y="3246120"/>
+            <a:ext cx="4754880" cy="274320"/>
           </a:xfrm>
           <a:prstGeom prst="rect">
             <a:avLst/>
@@ -5876,7 +5876,7 @@
                 <a:ea typeface="Arial" pitchFamily="34" charset="-122"/>
                 <a:cs typeface="Arial" pitchFamily="34" charset="-120"/>
               </a:rPr>
-              <a:t>ROLE</a:t>
+              <a:t>MOBILE APP DEVELOPER</a:t>
             </a:r>
             <a:endParaRPr lang="en-US" sz="1100" dirty="0"/>
           </a:p>
@@ -5890,8 +5890,8 @@
         </p:nvSpPr>
         <p:spPr>
           <a:xfrm>
-            <a:off x="4663440" y="3520440"/>
-            <a:ext cx="2834640" cy="548640"/>
+            <a:off x="6428232" y="3566160"/>
+            <a:ext cx="4754880" cy="548640"/>
           </a:xfrm>
           <a:prstGeom prst="rect">
             <a:avLst/>
@@ -5909,13 +5909,13 @@
             <a:r>
               <a:rPr lang="en-US" sz="2400" b="1" dirty="0">
                 <a:solidFill>
-                  <a:srgbClr val="0F9F6E"/>
-                </a:solidFill>
-                <a:latin typeface="Arial" pitchFamily="34" charset="0"/>
-                <a:ea typeface="Arial" pitchFamily="34" charset="-122"/>
-                <a:cs typeface="Arial" pitchFamily="34" charset="-120"/>
-              </a:rPr>
-              <a:t>[Name]</a:t>
+                  <a:srgbClr val="0F1F1A"/>
+                </a:solidFill>
+                <a:latin typeface="Arial" pitchFamily="34" charset="0"/>
+                <a:ea typeface="Arial" pitchFamily="34" charset="-122"/>
+                <a:cs typeface="Arial" pitchFamily="34" charset="-120"/>
+              </a:rPr>
+              <a:t>Alaa Qtishat</a:t>
             </a:r>
             <a:endParaRPr lang="en-US" sz="2400" dirty="0"/>
           </a:p>
@@ -5929,8 +5929,8 @@
         </p:nvSpPr>
         <p:spPr>
           <a:xfrm>
-            <a:off x="4663440" y="4114800"/>
-            <a:ext cx="2834640" cy="1097280"/>
+            <a:off x="6428232" y="4160520"/>
+            <a:ext cx="4754880" cy="1645920"/>
           </a:xfrm>
           <a:prstGeom prst="rect">
             <a:avLst/>
@@ -5946,168 +5946,17 @@
               <a:buNone/>
             </a:pPr>
             <a:r>
-              <a:rPr lang="en-US" sz="1700" dirty="0">
-                <a:solidFill>
-                  <a:srgbClr val="333333"/>
-                </a:solidFill>
-                <a:latin typeface="Arial" pitchFamily="34" charset="0"/>
-                <a:ea typeface="Arial" pitchFamily="34" charset="-122"/>
-                <a:cs typeface="Arial" pitchFamily="34" charset="-120"/>
-              </a:rPr>
-              <a:t>[Role]</a:t>
-            </a:r>
-            <a:endParaRPr lang="en-US" sz="1700" dirty="0"/>
-          </a:p>
-        </p:txBody>
-      </p:sp>
-      <p:sp>
-        <p:nvSpPr>
-          <p:cNvPr id="15" name="Shape 13"/>
-          <p:cNvSpPr/>
-          <p:nvPr/>
-        </p:nvSpPr>
-        <p:spPr>
-          <a:xfrm>
-            <a:off x="8046720" y="3017520"/>
-            <a:ext cx="3383280" cy="2377440"/>
-          </a:xfrm>
-          <a:prstGeom prst="roundRect">
-            <a:avLst>
-              <a:gd name="adj" fmla="val 6923"/>
-            </a:avLst>
-          </a:prstGeom>
-          <a:solidFill>
-            <a:srgbClr val="FFFFFF"/>
-          </a:solidFill>
-          <a:ln w="12700">
-            <a:solidFill>
-              <a:srgbClr val="E3E9E6"/>
-            </a:solidFill>
-            <a:prstDash val="solid"/>
-          </a:ln>
-          <a:effectLst>
-            <a:outerShdw sx="100000" sy="100000" kx="0" ky="0" algn="bl" rotWithShape="0" blurRad="127000" dist="38100" dir="5400000">
-              <a:srgbClr val="103020">
-                <a:alpha val="12000"/>
-              </a:srgbClr>
-            </a:outerShdw>
-          </a:effectLst>
-        </p:spPr>
-      </p:sp>
-      <p:sp>
-        <p:nvSpPr>
-          <p:cNvPr id="16" name="Text 14"/>
-          <p:cNvSpPr/>
-          <p:nvPr/>
-        </p:nvSpPr>
-        <p:spPr>
-          <a:xfrm>
-            <a:off x="8321040" y="3200400"/>
-            <a:ext cx="2834640" cy="274320"/>
-          </a:xfrm>
-          <a:prstGeom prst="rect">
-            <a:avLst/>
-          </a:prstGeom>
-          <a:noFill/>
-          <a:ln/>
-        </p:spPr>
-        <p:txBody>
-          <a:bodyPr wrap="square" rtlCol="0" anchor="ctr"/>
-          <a:lstStyle/>
-          <a:p>
-            <a:pPr indent="0" marL="0">
-              <a:buNone/>
-            </a:pPr>
-            <a:r>
-              <a:rPr lang="en-US" sz="1100" b="1" dirty="0">
-                <a:solidFill>
-                  <a:srgbClr val="0F9F6E"/>
-                </a:solidFill>
-                <a:latin typeface="Arial" pitchFamily="34" charset="0"/>
-                <a:ea typeface="Arial" pitchFamily="34" charset="-122"/>
-                <a:cs typeface="Arial" pitchFamily="34" charset="-120"/>
-              </a:rPr>
-              <a:t>ROLE</a:t>
-            </a:r>
-            <a:endParaRPr lang="en-US" sz="1100" dirty="0"/>
-          </a:p>
-        </p:txBody>
-      </p:sp>
-      <p:sp>
-        <p:nvSpPr>
-          <p:cNvPr id="17" name="Text 15"/>
-          <p:cNvSpPr/>
-          <p:nvPr/>
-        </p:nvSpPr>
-        <p:spPr>
-          <a:xfrm>
-            <a:off x="8321040" y="3520440"/>
-            <a:ext cx="2834640" cy="548640"/>
-          </a:xfrm>
-          <a:prstGeom prst="rect">
-            <a:avLst/>
-          </a:prstGeom>
-          <a:noFill/>
-          <a:ln/>
-        </p:spPr>
-        <p:txBody>
-          <a:bodyPr wrap="square" rtlCol="0" anchor="ctr"/>
-          <a:lstStyle/>
-          <a:p>
-            <a:pPr indent="0" marL="0">
-              <a:buNone/>
-            </a:pPr>
-            <a:r>
-              <a:rPr lang="en-US" sz="2400" b="1" dirty="0">
-                <a:solidFill>
-                  <a:srgbClr val="0F9F6E"/>
-                </a:solidFill>
-                <a:latin typeface="Arial" pitchFamily="34" charset="0"/>
-                <a:ea typeface="Arial" pitchFamily="34" charset="-122"/>
-                <a:cs typeface="Arial" pitchFamily="34" charset="-120"/>
-              </a:rPr>
-              <a:t>[Name]</a:t>
-            </a:r>
-            <a:endParaRPr lang="en-US" sz="2400" dirty="0"/>
-          </a:p>
-        </p:txBody>
-      </p:sp>
-      <p:sp>
-        <p:nvSpPr>
-          <p:cNvPr id="18" name="Text 16"/>
-          <p:cNvSpPr/>
-          <p:nvPr/>
-        </p:nvSpPr>
-        <p:spPr>
-          <a:xfrm>
-            <a:off x="8321040" y="4114800"/>
-            <a:ext cx="2834640" cy="1097280"/>
-          </a:xfrm>
-          <a:prstGeom prst="rect">
-            <a:avLst/>
-          </a:prstGeom>
-          <a:noFill/>
-          <a:ln/>
-        </p:spPr>
-        <p:txBody>
-          <a:bodyPr wrap="square" rtlCol="0" anchor="t"/>
-          <a:lstStyle/>
-          <a:p>
-            <a:pPr indent="0" marL="0">
-              <a:buNone/>
-            </a:pPr>
-            <a:r>
-              <a:rPr lang="en-US" sz="1700" dirty="0">
-                <a:solidFill>
-                  <a:srgbClr val="333333"/>
-                </a:solidFill>
-                <a:latin typeface="Arial" pitchFamily="34" charset="0"/>
-                <a:ea typeface="Arial" pitchFamily="34" charset="-122"/>
-                <a:cs typeface="Arial" pitchFamily="34" charset="-120"/>
-              </a:rPr>
-              <a:t>[Role]</a:t>
-            </a:r>
-            <a:endParaRPr lang="en-US" sz="1700" dirty="0"/>
+              <a:rPr lang="en-US" sz="1800" dirty="0">
+                <a:solidFill>
+                  <a:srgbClr val="222222"/>
+                </a:solidFill>
+                <a:latin typeface="Arial" pitchFamily="34" charset="0"/>
+                <a:ea typeface="Arial" pitchFamily="34" charset="-122"/>
+                <a:cs typeface="Arial" pitchFamily="34" charset="-120"/>
+              </a:rPr>
+              <a:t>Mobile app developer</a:t>
+            </a:r>
+            <a:endParaRPr lang="en-US" sz="1800" dirty="0"/>
           </a:p>
         </p:txBody>
       </p:sp>

</xml_diff>